<commit_message>
Mejora interfaz, documentación y evidencias EPE3
</commit_message>
<xml_diff>
--- a/entregables/Presentacion_EPE3.pptx
+++ b/entregables/Presentacion_EPE3.pptx
@@ -2,21 +2,22 @@
 <file path=ppt/presentation.xml><?xml version="1.0" encoding="utf-8"?>
 <p:presentation xmlns:p="http://schemas.openxmlformats.org/presentationml/2006/main">
   <p:sldMasterIdLst>
-    <p:sldMasterId xmlns:r="http://schemas.openxmlformats.org/officeDocument/2006/relationships" id="2147483648" r:id="Redb9f79d0e5d4aa6"/>
+    <p:sldMasterId xmlns:r="http://schemas.openxmlformats.org/officeDocument/2006/relationships" id="2147483648" r:id="Re5b9c118a9554aab"/>
   </p:sldMasterIdLst>
   <p:notesMasterIdLst>
-    <p:notesMasterId xmlns:r="http://schemas.openxmlformats.org/officeDocument/2006/relationships" r:id="Rac1866c811a44d7d"/>
+    <p:notesMasterId xmlns:r="http://schemas.openxmlformats.org/officeDocument/2006/relationships" r:id="R97cae7b197de4f54"/>
   </p:notesMasterIdLst>
   <p:sldIdLst>
-    <p:sldId xmlns:r="http://schemas.openxmlformats.org/officeDocument/2006/relationships" id="256" r:id="R6ca40f0227484c16"/>
-    <p:sldId xmlns:r="http://schemas.openxmlformats.org/officeDocument/2006/relationships" id="257" r:id="R8402ab438cd64e25"/>
-    <p:sldId xmlns:r="http://schemas.openxmlformats.org/officeDocument/2006/relationships" id="258" r:id="R60d2e8c19dbd45fc"/>
-    <p:sldId xmlns:r="http://schemas.openxmlformats.org/officeDocument/2006/relationships" id="259" r:id="R764dd4ae4c7746f2"/>
-    <p:sldId xmlns:r="http://schemas.openxmlformats.org/officeDocument/2006/relationships" id="260" r:id="R34a712706cad4c98"/>
-    <p:sldId xmlns:r="http://schemas.openxmlformats.org/officeDocument/2006/relationships" id="261" r:id="R1b01405052b44baa"/>
-    <p:sldId xmlns:r="http://schemas.openxmlformats.org/officeDocument/2006/relationships" id="262" r:id="R1fdbafb8d83f45b2"/>
-    <p:sldId xmlns:r="http://schemas.openxmlformats.org/officeDocument/2006/relationships" id="263" r:id="R28f636c2f40348dd"/>
-    <p:sldId xmlns:r="http://schemas.openxmlformats.org/officeDocument/2006/relationships" id="264" r:id="R57a33ac9c7fc43fe"/>
+    <p:sldId xmlns:r="http://schemas.openxmlformats.org/officeDocument/2006/relationships" id="256" r:id="R017dc9246f7f4506"/>
+    <p:sldId xmlns:r="http://schemas.openxmlformats.org/officeDocument/2006/relationships" id="257" r:id="R13c6516c333c4cee"/>
+    <p:sldId xmlns:r="http://schemas.openxmlformats.org/officeDocument/2006/relationships" id="258" r:id="Recd560dade5544a5"/>
+    <p:sldId xmlns:r="http://schemas.openxmlformats.org/officeDocument/2006/relationships" id="259" r:id="R18ae6d2f46534a9f"/>
+    <p:sldId xmlns:r="http://schemas.openxmlformats.org/officeDocument/2006/relationships" id="260" r:id="Ra75ff16ce7144d4a"/>
+    <p:sldId xmlns:r="http://schemas.openxmlformats.org/officeDocument/2006/relationships" id="261" r:id="Re50b9ee061d64773"/>
+    <p:sldId xmlns:r="http://schemas.openxmlformats.org/officeDocument/2006/relationships" id="262" r:id="R071ed0b4c77f469a"/>
+    <p:sldId xmlns:r="http://schemas.openxmlformats.org/officeDocument/2006/relationships" id="263" r:id="R698d30c59e1f4483"/>
+    <p:sldId xmlns:r="http://schemas.openxmlformats.org/officeDocument/2006/relationships" id="264" r:id="Rdcf4eaac499d4245"/>
+    <p:sldId xmlns:r="http://schemas.openxmlformats.org/officeDocument/2006/relationships" id="265" r:id="R7fe0c9cf7bae450e"/>
   </p:sldIdLst>
   <p:sldSz cx="12192000" cy="6858000"/>
   <p:notesSz cx="6858000" cy="9144000"/>
@@ -480,6 +481,76 @@
 </p:notes>
 </file>
 
+<file path=ppt/notesSlides/notesSlide10.xml><?xml version="1.0" encoding="utf-8"?>
+<p:notes xmlns:p="http://schemas.openxmlformats.org/presentationml/2006/main">
+  <p:cSld>
+    <p:spTree>
+      <p:nvGrpSpPr>
+        <p:cNvPr id="1" name=""/>
+        <p:cNvGrpSpPr/>
+        <p:nvPr/>
+      </p:nvGrpSpPr>
+      <p:grpSpPr>
+        <a:xfrm xmlns:a="http://schemas.openxmlformats.org/drawingml/2006/main"/>
+      </p:grpSpPr>
+      <p:sp>
+        <p:nvSpPr>
+          <p:cNvPr id="2" name="Slide Image Placeholder 1"/>
+          <p:cNvSpPr>
+            <a:spLocks xmlns:a="http://schemas.openxmlformats.org/drawingml/2006/main" noGrp="1"/>
+          </p:cNvSpPr>
+          <p:nvPr>
+            <p:ph type="sldImg" idx="0"/>
+          </p:nvPr>
+        </p:nvSpPr>
+        <p:spPr/>
+      </p:sp>
+      <p:sp>
+        <p:nvSpPr>
+          <p:cNvPr id="3" name="Notes Placeholder 2"/>
+          <p:cNvSpPr>
+            <a:spLocks xmlns:a="http://schemas.openxmlformats.org/drawingml/2006/main" noGrp="1"/>
+          </p:cNvSpPr>
+          <p:nvPr>
+            <p:ph type="body" idx="1"/>
+          </p:nvPr>
+        </p:nvSpPr>
+        <p:spPr/>
+        <p:txBody>
+          <a:bodyPr xmlns:a="http://schemas.openxmlformats.org/drawingml/2006/main"/>
+          <a:lstStyle xmlns:a="http://schemas.openxmlformats.org/drawingml/2006/main"/>
+          <a:p xmlns:a="http://schemas.openxmlformats.org/drawingml/2006/main">
+            <a:r>
+              <a:t>Fuente de requisitos: P_ACTIVIDAD_2024 VF.pdf, actividad evaluativa IPCHILE. Repositorio: https://github.com/RenatoLV/EPE3-IPCHILE-ING. Verificar acceso del docente y el mismo commit.</a:t>
+            </a:r>
+          </a:p>
+        </p:txBody>
+      </p:sp>
+      <p:sp>
+        <p:nvSpPr>
+          <p:cNvPr id="4" name="Slide Number Placeholder 3"/>
+          <p:cNvSpPr>
+            <a:spLocks xmlns:a="http://schemas.openxmlformats.org/drawingml/2006/main" noGrp="1"/>
+          </p:cNvSpPr>
+          <p:nvPr>
+            <p:ph type="sldNum" idx="5"/>
+          </p:nvPr>
+        </p:nvSpPr>
+        <p:spPr/>
+        <p:txBody>
+          <a:bodyPr xmlns:a="http://schemas.openxmlformats.org/drawingml/2006/main"/>
+          <a:lstStyle xmlns:a="http://schemas.openxmlformats.org/drawingml/2006/main"/>
+          <a:p xmlns:a="http://schemas.openxmlformats.org/drawingml/2006/main"/>
+        </p:txBody>
+      </p:sp>
+    </p:spTree>
+  </p:cSld>
+  <p:clrMapOvr>
+    <a:masterClrMapping xmlns:a="http://schemas.openxmlformats.org/drawingml/2006/main"/>
+  </p:clrMapOvr>
+</p:notes>
+</file>
+
 <file path=ppt/notesSlides/notesSlide2.xml><?xml version="1.0" encoding="utf-8"?>
 <p:notes xmlns:p="http://schemas.openxmlformats.org/presentationml/2006/main">
   <p:cSld>
@@ -730,7 +801,7 @@
           <a:lstStyle xmlns:a="http://schemas.openxmlformats.org/drawingml/2006/main"/>
           <a:p xmlns:a="http://schemas.openxmlformats.org/drawingml/2006/main">
             <a:r>
-              <a:t>Captura real de artifacts/interfaz.png. Ejemplo: zona 1, sábado, diciembre, promoción 1 y rezago 95.0. Datos sintéticos.</a:t>
+              <a:t>Captura real de artifacts/interfaz_resumen.png. Ejemplo: zona 1, sábado 19 de septiembre de 2026, promoción 1 y rezago 95.0. Datos sintéticos.</a:t>
             </a:r>
           </a:p>
         </p:txBody>
@@ -870,7 +941,7 @@
           <a:lstStyle xmlns:a="http://schemas.openxmlformats.org/drawingml/2006/main"/>
           <a:p xmlns:a="http://schemas.openxmlformats.org/drawingml/2006/main">
             <a:r>
-              <a:t>Fuentes: artifacts/pruebas.txt y artifacts/carga.json. 100 solicitudes con concurrencia 10 por flujo y una petición previa de calentamiento. Windows local.</a:t>
+              <a:t>Captura de /docs del servicio FastAPI en ejecución local. La documentación es autónoma y /openapi.json conserva el esquema generado por FastAPI.</a:t>
             </a:r>
           </a:p>
         </p:txBody>
@@ -940,7 +1011,7 @@
           <a:lstStyle xmlns:a="http://schemas.openxmlformats.org/drawingml/2006/main"/>
           <a:p xmlns:a="http://schemas.openxmlformats.org/drawingml/2006/main">
             <a:r>
-              <a:t>La usabilidad humana no se ha ejecutado. Protocolo completo en PLAN_DE_TRABAJO.md. No se dispone de datos operacionales autorizados.</a:t>
+              <a:t>Fuentes: test_app.py, salida actual de pytest y artifacts/carga.json. 100 solicitudes con concurrencia 10 por flujo y una petición previa de calentamiento. Windows local.</a:t>
             </a:r>
           </a:p>
         </p:txBody>
@@ -1010,7 +1081,7 @@
           <a:lstStyle xmlns:a="http://schemas.openxmlformats.org/drawingml/2006/main"/>
           <a:p xmlns:a="http://schemas.openxmlformats.org/drawingml/2006/main">
             <a:r>
-              <a:t>Fuente de requisitos: P_ACTIVIDAD_2024 VF.pdf, actividad evaluativa IPCHILE. El repositorio está preparado localmente y aún no está publicado.</a:t>
+              <a:t>La usabilidad humana no se ha ejecutado. Protocolo completo en PLAN_DE_TRABAJO.md. No se dispone de datos operacionales autorizados.</a:t>
             </a:r>
           </a:p>
         </p:txBody>
@@ -1078,7 +1149,7 @@
   </p:cSld>
   <p:clrMap bg1="lt1" tx1="dk1" bg2="lt2" tx2="dk2" accent1="accent1" accent2="accent2" accent3="accent3" accent4="accent4" accent5="accent5" accent6="accent6" hlink="hlink" folHlink="folHlink"/>
   <p:sldLayoutIdLst>
-    <p:sldLayoutId xmlns:r="http://schemas.openxmlformats.org/officeDocument/2006/relationships" id="2147483649" r:id="R2cec84e230ca4915"/>
+    <p:sldLayoutId xmlns:r="http://schemas.openxmlformats.org/officeDocument/2006/relationships" id="2147483649" r:id="R080cb19a2d474528"/>
   </p:sldLayoutIdLst>
   <p:txStyles>
     <p:titleStyle>
@@ -1844,7 +1915,7 @@
           <p:cNvPr id="6" name="">
             <a:extLst xmlns:a="http://schemas.openxmlformats.org/drawingml/2006/main">
               <a:ext uri="{FF2B5EF4-FFF2-40B4-BE49-F238E27FC236}">
-                <a16:creationId xmlns:a16="http://schemas.microsoft.com/office/drawing/2014/main" id="{847F1FCE-87B5-4929-8804-D791DA8B3B69}"/>
+                <a16:creationId xmlns:a16="http://schemas.microsoft.com/office/drawing/2014/main" id="{5FD8058B-C56C-4DEF-92AF-1C4F8947BEA1}"/>
               </a:ext>
             </a:extLst>
           </p:cNvPr>
@@ -1924,7 +1995,7 @@
           <p:cNvPr id="2" name="">
             <a:extLst xmlns:a="http://schemas.openxmlformats.org/drawingml/2006/main">
               <a:ext uri="{FF2B5EF4-FFF2-40B4-BE49-F238E27FC236}">
-                <a16:creationId xmlns:a16="http://schemas.microsoft.com/office/drawing/2014/main" id="{9C4614B5-2D12-401C-9005-345EE14DE0E3}"/>
+                <a16:creationId xmlns:a16="http://schemas.microsoft.com/office/drawing/2014/main" id="{DBB3BD17-EF99-45D0-8267-27EFCD80D094}"/>
               </a:ext>
             </a:extLst>
           </p:cNvPr>
@@ -1981,7 +2052,7 @@
           <p:cNvPr id="3" name="">
             <a:extLst xmlns:a="http://schemas.openxmlformats.org/drawingml/2006/main">
               <a:ext uri="{FF2B5EF4-FFF2-40B4-BE49-F238E27FC236}">
-                <a16:creationId xmlns:a16="http://schemas.microsoft.com/office/drawing/2014/main" id="{43C1018C-FF53-415E-B754-C4DF073A9FC2}"/>
+                <a16:creationId xmlns:a16="http://schemas.microsoft.com/office/drawing/2014/main" id="{30FA8AE9-A889-403A-AE72-8557E0F7E1F9}"/>
               </a:ext>
             </a:extLst>
           </p:cNvPr>
@@ -2038,7 +2109,7 @@
           <p:cNvPr id="4" name="">
             <a:extLst xmlns:a="http://schemas.openxmlformats.org/drawingml/2006/main">
               <a:ext uri="{FF2B5EF4-FFF2-40B4-BE49-F238E27FC236}">
-                <a16:creationId xmlns:a16="http://schemas.microsoft.com/office/drawing/2014/main" id="{2B875ABC-7A83-4616-B3A5-096CCB88C27F}"/>
+                <a16:creationId xmlns:a16="http://schemas.microsoft.com/office/drawing/2014/main" id="{F9123239-0795-4BA2-AC6C-D513DC385815}"/>
               </a:ext>
             </a:extLst>
           </p:cNvPr>
@@ -2095,7 +2166,7 @@
           <p:cNvPr id="5" name="">
             <a:extLst xmlns:a="http://schemas.openxmlformats.org/drawingml/2006/main">
               <a:ext uri="{FF2B5EF4-FFF2-40B4-BE49-F238E27FC236}">
-                <a16:creationId xmlns:a16="http://schemas.microsoft.com/office/drawing/2014/main" id="{07C449FF-8289-42E8-BF47-BD617A714F2E}"/>
+                <a16:creationId xmlns:a16="http://schemas.microsoft.com/office/drawing/2014/main" id="{A0651707-7CEB-4DF0-869C-F60F7F1B86F1}"/>
               </a:ext>
             </a:extLst>
           </p:cNvPr>
@@ -2150,7 +2221,344 @@
     </p:spTree>
     <p:extLst>
       <p:ext uri="{BB962C8B-B14F-4D97-AF65-F5344CB8AC3E}">
-        <p14:creationId xmlns:p14="http://schemas.microsoft.com/office/powerpoint/2010/main" val="870490912"/>
+        <p14:creationId xmlns:p14="http://schemas.microsoft.com/office/powerpoint/2010/main" val="546443705"/>
+      </p:ext>
+    </p:extLst>
+  </p:cSld>
+</p:sld>
+</file>
+
+<file path=ppt/slides/slide10.xml><?xml version="1.0" encoding="utf-8"?>
+<p:sld xmlns:p="http://schemas.openxmlformats.org/presentationml/2006/main">
+  <p:cSld>
+    <p:bg>
+      <p:bgPr>
+        <a:solidFill xmlns:a="http://schemas.openxmlformats.org/drawingml/2006/main">
+          <a:srgbClr val="F5F7F8"/>
+        </a:solidFill>
+      </p:bgPr>
+    </p:bg>
+    <p:spTree>
+      <p:nvGrpSpPr>
+        <p:cNvPr id="1" name=""/>
+        <p:cNvGrpSpPr/>
+        <p:nvPr/>
+      </p:nvGrpSpPr>
+      <p:grpSpPr>
+        <a:xfrm xmlns:a="http://schemas.openxmlformats.org/drawingml/2006/main"/>
+      </p:grpSpPr>
+      <p:sp>
+        <p:nvSpPr>
+          <p:cNvPr id="6" name="">
+            <a:extLst xmlns:a="http://schemas.openxmlformats.org/drawingml/2006/main">
+              <a:ext uri="{FF2B5EF4-FFF2-40B4-BE49-F238E27FC236}">
+                <a16:creationId xmlns:a16="http://schemas.microsoft.com/office/drawing/2014/main" id="{2C2FBE95-EA31-47AF-9673-8D49B9D22328}"/>
+              </a:ext>
+            </a:extLst>
+          </p:cNvPr>
+          <p:cNvSpPr>
+            <a:spLocks xmlns:a="http://schemas.openxmlformats.org/drawingml/2006/main" noGrp="1"/>
+          </p:cNvSpPr>
+          <p:nvPr/>
+        </p:nvSpPr>
+        <p:spPr>
+          <a:xfrm xmlns:a="http://schemas.openxmlformats.org/drawingml/2006/main">
+            <a:off x="619125" y="428625"/>
+            <a:ext cx="10858500" cy="1047750"/>
+          </a:xfrm>
+          <a:prstGeom xmlns:a="http://schemas.openxmlformats.org/drawingml/2006/main" prst="rect">
+            <a:avLst/>
+          </a:prstGeom>
+          <a:noFill xmlns:a="http://schemas.openxmlformats.org/drawingml/2006/main"/>
+          <a:ln xmlns:a="http://schemas.openxmlformats.org/drawingml/2006/main" w="0">
+            <a:noFill/>
+          </a:ln>
+        </p:spPr>
+        <p:txBody>
+          <a:bodyPr xmlns:a="http://schemas.openxmlformats.org/drawingml/2006/main">
+            <a:noAutofit/>
+          </a:bodyPr>
+          <a:lstStyle xmlns:a="http://schemas.openxmlformats.org/drawingml/2006/main"/>
+          <a:p xmlns:a="http://schemas.openxmlformats.org/drawingml/2006/main">
+            <a:pPr>
+              <a:defRPr sz="3300" b="1">
+                <a:solidFill>
+                  <a:srgbClr val="123B50"/>
+                </a:solidFill>
+                <a:latin typeface="Calibri"/>
+                <a:ea typeface="Calibri"/>
+                <a:cs typeface="Calibri"/>
+              </a:defRPr>
+            </a:pPr>
+            <a:r>
+              <a:rPr sz="3300" b="1">
+                <a:solidFill>
+                  <a:srgbClr val="123B50"/>
+                </a:solidFill>
+                <a:latin typeface="Calibri"/>
+                <a:ea typeface="Calibri"/>
+                <a:cs typeface="Calibri"/>
+              </a:rPr>
+              <a:t>Entregables y cierre</a:t>
+            </a:r>
+          </a:p>
+        </p:txBody>
+      </p:sp>
+      <p:sp>
+        <p:nvSpPr>
+          <p:cNvPr id="2" name="">
+            <a:extLst xmlns:a="http://schemas.openxmlformats.org/drawingml/2006/main">
+              <a:ext uri="{FF2B5EF4-FFF2-40B4-BE49-F238E27FC236}">
+                <a16:creationId xmlns:a16="http://schemas.microsoft.com/office/drawing/2014/main" id="{DA379BE1-B4C5-4E67-9FEF-095657582082}"/>
+              </a:ext>
+            </a:extLst>
+          </p:cNvPr>
+          <p:cNvSpPr>
+            <a:spLocks xmlns:a="http://schemas.openxmlformats.org/drawingml/2006/main" noGrp="1"/>
+          </p:cNvSpPr>
+          <p:nvPr/>
+        </p:nvSpPr>
+        <p:spPr>
+          <a:xfrm xmlns:a="http://schemas.openxmlformats.org/drawingml/2006/main">
+            <a:off x="619125" y="6334125"/>
+            <a:ext cx="10858500" cy="285750"/>
+          </a:xfrm>
+          <a:prstGeom xmlns:a="http://schemas.openxmlformats.org/drawingml/2006/main" prst="rect">
+            <a:avLst/>
+          </a:prstGeom>
+          <a:noFill xmlns:a="http://schemas.openxmlformats.org/drawingml/2006/main"/>
+          <a:ln xmlns:a="http://schemas.openxmlformats.org/drawingml/2006/main" w="0">
+            <a:noFill/>
+          </a:ln>
+        </p:spPr>
+        <p:txBody>
+          <a:bodyPr xmlns:a="http://schemas.openxmlformats.org/drawingml/2006/main">
+            <a:noAutofit/>
+          </a:bodyPr>
+          <a:lstStyle xmlns:a="http://schemas.openxmlformats.org/drawingml/2006/main"/>
+          <a:p xmlns:a="http://schemas.openxmlformats.org/drawingml/2006/main">
+            <a:pPr>
+              <a:defRPr sz="1425" b="0">
+                <a:solidFill>
+                  <a:srgbClr val="506571"/>
+                </a:solidFill>
+                <a:latin typeface="Calibri"/>
+                <a:ea typeface="Calibri"/>
+                <a:cs typeface="Calibri"/>
+              </a:defRPr>
+            </a:pPr>
+            <a:r>
+              <a:rPr sz="1425" b="0">
+                <a:solidFill>
+                  <a:srgbClr val="506571"/>
+                </a:solidFill>
+                <a:latin typeface="Calibri"/>
+                <a:ea typeface="Calibri"/>
+                <a:cs typeface="Calibri"/>
+              </a:rPr>
+              <a:t>NexaFlow     EPE 3     10</a:t>
+            </a:r>
+          </a:p>
+        </p:txBody>
+      </p:sp>
+      <p:sp>
+        <p:nvSpPr>
+          <p:cNvPr id="3" name="">
+            <a:extLst xmlns:a="http://schemas.openxmlformats.org/drawingml/2006/main">
+              <a:ext uri="{FF2B5EF4-FFF2-40B4-BE49-F238E27FC236}">
+                <a16:creationId xmlns:a16="http://schemas.microsoft.com/office/drawing/2014/main" id="{D83763E5-4499-4073-8696-A88C1D4C0927}"/>
+              </a:ext>
+            </a:extLst>
+          </p:cNvPr>
+          <p:cNvSpPr>
+            <a:spLocks xmlns:a="http://schemas.openxmlformats.org/drawingml/2006/main" noGrp="1"/>
+          </p:cNvSpPr>
+          <p:nvPr/>
+        </p:nvSpPr>
+        <p:spPr>
+          <a:xfrm xmlns:a="http://schemas.openxmlformats.org/drawingml/2006/main">
+            <a:off x="619125" y="1809750"/>
+            <a:ext cx="10477500" cy="904875"/>
+          </a:xfrm>
+          <a:prstGeom xmlns:a="http://schemas.openxmlformats.org/drawingml/2006/main" prst="rect">
+            <a:avLst/>
+          </a:prstGeom>
+          <a:noFill xmlns:a="http://schemas.openxmlformats.org/drawingml/2006/main"/>
+          <a:ln xmlns:a="http://schemas.openxmlformats.org/drawingml/2006/main" w="0">
+            <a:noFill/>
+          </a:ln>
+        </p:spPr>
+        <p:txBody>
+          <a:bodyPr xmlns:a="http://schemas.openxmlformats.org/drawingml/2006/main">
+            <a:noAutofit/>
+          </a:bodyPr>
+          <a:lstStyle xmlns:a="http://schemas.openxmlformats.org/drawingml/2006/main"/>
+          <a:p xmlns:a="http://schemas.openxmlformats.org/drawingml/2006/main">
+            <a:pPr>
+              <a:defRPr sz="2475" b="0">
+                <a:solidFill>
+                  <a:srgbClr val="173345"/>
+                </a:solidFill>
+                <a:latin typeface="Calibri"/>
+                <a:ea typeface="Calibri"/>
+                <a:cs typeface="Calibri"/>
+              </a:defRPr>
+            </a:pPr>
+            <a:r>
+              <a:rPr sz="2475" b="0">
+                <a:solidFill>
+                  <a:srgbClr val="173345"/>
+                </a:solidFill>
+                <a:latin typeface="Calibri"/>
+                <a:ea typeface="Calibri"/>
+                <a:cs typeface="Calibri"/>
+              </a:rPr>
+              <a:t>Informe Word y PDF con desarrollo y evidencias</a:t>
+            </a:r>
+          </a:p>
+        </p:txBody>
+      </p:sp>
+      <p:sp>
+        <p:nvSpPr>
+          <p:cNvPr id="4" name="">
+            <a:extLst xmlns:a="http://schemas.openxmlformats.org/drawingml/2006/main">
+              <a:ext uri="{FF2B5EF4-FFF2-40B4-BE49-F238E27FC236}">
+                <a16:creationId xmlns:a16="http://schemas.microsoft.com/office/drawing/2014/main" id="{F681A878-590F-4A22-9762-7FBA4A2F80E6}"/>
+              </a:ext>
+            </a:extLst>
+          </p:cNvPr>
+          <p:cNvSpPr>
+            <a:spLocks xmlns:a="http://schemas.openxmlformats.org/drawingml/2006/main" noGrp="1"/>
+          </p:cNvSpPr>
+          <p:nvPr/>
+        </p:nvSpPr>
+        <p:spPr>
+          <a:xfrm xmlns:a="http://schemas.openxmlformats.org/drawingml/2006/main">
+            <a:off x="619125" y="3143250"/>
+            <a:ext cx="10477500" cy="762000"/>
+          </a:xfrm>
+          <a:prstGeom xmlns:a="http://schemas.openxmlformats.org/drawingml/2006/main" prst="rect">
+            <a:avLst/>
+          </a:prstGeom>
+          <a:noFill xmlns:a="http://schemas.openxmlformats.org/drawingml/2006/main"/>
+          <a:ln xmlns:a="http://schemas.openxmlformats.org/drawingml/2006/main" w="0">
+            <a:noFill/>
+          </a:ln>
+        </p:spPr>
+        <p:txBody>
+          <a:bodyPr xmlns:a="http://schemas.openxmlformats.org/drawingml/2006/main">
+            <a:noAutofit/>
+          </a:bodyPr>
+          <a:lstStyle xmlns:a="http://schemas.openxmlformats.org/drawingml/2006/main"/>
+          <a:p xmlns:a="http://schemas.openxmlformats.org/drawingml/2006/main">
+            <a:pPr>
+              <a:defRPr sz="2475" b="0">
+                <a:solidFill>
+                  <a:srgbClr val="173345"/>
+                </a:solidFill>
+                <a:latin typeface="Calibri"/>
+                <a:ea typeface="Calibri"/>
+                <a:cs typeface="Calibri"/>
+              </a:defRPr>
+            </a:pPr>
+            <a:r>
+              <a:rPr sz="2475" b="0">
+                <a:solidFill>
+                  <a:srgbClr val="173345"/>
+                </a:solidFill>
+                <a:latin typeface="Calibri"/>
+                <a:ea typeface="Calibri"/>
+                <a:cs typeface="Calibri"/>
+              </a:rPr>
+              <a:t>Código, modelo, pruebas y evidencia de ejecución</a:t>
+            </a:r>
+          </a:p>
+        </p:txBody>
+      </p:sp>
+      <p:sp>
+        <p:nvSpPr>
+          <p:cNvPr id="5" name="">
+            <a:extLst xmlns:a="http://schemas.openxmlformats.org/drawingml/2006/main">
+              <a:ext uri="{FF2B5EF4-FFF2-40B4-BE49-F238E27FC236}">
+                <a16:creationId xmlns:a16="http://schemas.microsoft.com/office/drawing/2014/main" id="{F033312A-683C-4373-9ECC-33EA76544EBE}"/>
+              </a:ext>
+            </a:extLst>
+          </p:cNvPr>
+          <p:cNvSpPr>
+            <a:spLocks xmlns:a="http://schemas.openxmlformats.org/drawingml/2006/main" noGrp="1"/>
+          </p:cNvSpPr>
+          <p:nvPr/>
+        </p:nvSpPr>
+        <p:spPr>
+          <a:xfrm xmlns:a="http://schemas.openxmlformats.org/drawingml/2006/main">
+            <a:off x="619125" y="4476750"/>
+            <a:ext cx="10477500" cy="1143000"/>
+          </a:xfrm>
+          <a:prstGeom xmlns:a="http://schemas.openxmlformats.org/drawingml/2006/main" prst="rect">
+            <a:avLst/>
+          </a:prstGeom>
+          <a:noFill xmlns:a="http://schemas.openxmlformats.org/drawingml/2006/main"/>
+          <a:ln xmlns:a="http://schemas.openxmlformats.org/drawingml/2006/main" w="0">
+            <a:noFill/>
+          </a:ln>
+        </p:spPr>
+        <p:txBody>
+          <a:bodyPr xmlns:a="http://schemas.openxmlformats.org/drawingml/2006/main">
+            <a:noAutofit/>
+          </a:bodyPr>
+          <a:lstStyle xmlns:a="http://schemas.openxmlformats.org/drawingml/2006/main"/>
+          <a:p xmlns:a="http://schemas.openxmlformats.org/drawingml/2006/main">
+            <a:pPr>
+              <a:defRPr sz="2325" b="1">
+                <a:solidFill>
+                  <a:srgbClr val="006B68"/>
+                </a:solidFill>
+                <a:latin typeface="Calibri"/>
+                <a:ea typeface="Calibri"/>
+                <a:cs typeface="Calibri"/>
+              </a:defRPr>
+            </a:pPr>
+            <a:r>
+              <a:rPr sz="2325" b="1">
+                <a:solidFill>
+                  <a:srgbClr val="006B68"/>
+                </a:solidFill>
+                <a:latin typeface="Calibri"/>
+                <a:ea typeface="Calibri"/>
+                <a:cs typeface="Calibri"/>
+              </a:rPr>
+              <a:t>Repositorio: github.com/RenatoLV/EPE3-IPCHILE-ING</a:t>
+            </a:r>
+          </a:p>
+          <a:p xmlns:a="http://schemas.openxmlformats.org/drawingml/2006/main">
+            <a:pPr>
+              <a:defRPr sz="2325" b="1">
+                <a:solidFill>
+                  <a:srgbClr val="006B68"/>
+                </a:solidFill>
+                <a:latin typeface="Calibri"/>
+                <a:ea typeface="Calibri"/>
+                <a:cs typeface="Calibri"/>
+              </a:defRPr>
+            </a:pPr>
+            <a:r>
+              <a:rPr sz="2325" b="1">
+                <a:solidFill>
+                  <a:srgbClr val="006B68"/>
+                </a:solidFill>
+                <a:latin typeface="Calibri"/>
+                <a:ea typeface="Calibri"/>
+                <a:cs typeface="Calibri"/>
+              </a:rPr>
+              <a:t>Pendiente: datos personales y prueba con usuarios reales</a:t>
+            </a:r>
+          </a:p>
+        </p:txBody>
+      </p:sp>
+    </p:spTree>
+    <p:extLst>
+      <p:ext uri="{BB962C8B-B14F-4D97-AF65-F5344CB8AC3E}">
+        <p14:creationId xmlns:p14="http://schemas.microsoft.com/office/powerpoint/2010/main" val="43952198"/>
       </p:ext>
     </p:extLst>
   </p:cSld>
@@ -2181,7 +2589,7 @@
           <p:cNvPr id="7" name="">
             <a:extLst xmlns:a="http://schemas.openxmlformats.org/drawingml/2006/main">
               <a:ext uri="{FF2B5EF4-FFF2-40B4-BE49-F238E27FC236}">
-                <a16:creationId xmlns:a16="http://schemas.microsoft.com/office/drawing/2014/main" id="{CBCEFEC8-6B64-4582-841A-F1656016073C}"/>
+                <a16:creationId xmlns:a16="http://schemas.microsoft.com/office/drawing/2014/main" id="{7DCFCDD8-1A10-4811-8242-A93F115F77D6}"/>
               </a:ext>
             </a:extLst>
           </p:cNvPr>
@@ -2238,7 +2646,7 @@
           <p:cNvPr id="2" name="">
             <a:extLst xmlns:a="http://schemas.openxmlformats.org/drawingml/2006/main">
               <a:ext uri="{FF2B5EF4-FFF2-40B4-BE49-F238E27FC236}">
-                <a16:creationId xmlns:a16="http://schemas.microsoft.com/office/drawing/2014/main" id="{698B9872-B70B-4217-882B-FB3D64B173F4}"/>
+                <a16:creationId xmlns:a16="http://schemas.microsoft.com/office/drawing/2014/main" id="{99F556F0-7ED4-49BC-9DB6-4BB2BD1031B8}"/>
               </a:ext>
             </a:extLst>
           </p:cNvPr>
@@ -2295,7 +2703,7 @@
           <p:cNvPr id="3" name="">
             <a:extLst xmlns:a="http://schemas.openxmlformats.org/drawingml/2006/main">
               <a:ext uri="{FF2B5EF4-FFF2-40B4-BE49-F238E27FC236}">
-                <a16:creationId xmlns:a16="http://schemas.microsoft.com/office/drawing/2014/main" id="{540777A4-D5AE-44D8-AAF1-04CAE6044B91}"/>
+                <a16:creationId xmlns:a16="http://schemas.microsoft.com/office/drawing/2014/main" id="{51D6CD08-09B5-4D89-B12F-214C7C00C523}"/>
               </a:ext>
             </a:extLst>
           </p:cNvPr>
@@ -2352,7 +2760,7 @@
           <p:cNvPr id="4" name="">
             <a:extLst xmlns:a="http://schemas.openxmlformats.org/drawingml/2006/main">
               <a:ext uri="{FF2B5EF4-FFF2-40B4-BE49-F238E27FC236}">
-                <a16:creationId xmlns:a16="http://schemas.microsoft.com/office/drawing/2014/main" id="{F776FA50-2364-4C0B-82B6-5DE109D7F59C}"/>
+                <a16:creationId xmlns:a16="http://schemas.microsoft.com/office/drawing/2014/main" id="{AD8259AE-35AB-41D3-83A4-C0E9313D252F}"/>
               </a:ext>
             </a:extLst>
           </p:cNvPr>
@@ -2409,7 +2817,7 @@
           <p:cNvPr id="5" name="">
             <a:extLst xmlns:a="http://schemas.openxmlformats.org/drawingml/2006/main">
               <a:ext uri="{FF2B5EF4-FFF2-40B4-BE49-F238E27FC236}">
-                <a16:creationId xmlns:a16="http://schemas.microsoft.com/office/drawing/2014/main" id="{69A345A5-23B3-4AEC-8518-00839BAECF61}"/>
+                <a16:creationId xmlns:a16="http://schemas.microsoft.com/office/drawing/2014/main" id="{C48CC4A1-6EB4-4C9C-9CF9-BE24ABEED198}"/>
               </a:ext>
             </a:extLst>
           </p:cNvPr>
@@ -2466,7 +2874,7 @@
           <p:cNvPr id="6" name="">
             <a:extLst xmlns:a="http://schemas.openxmlformats.org/drawingml/2006/main">
               <a:ext uri="{FF2B5EF4-FFF2-40B4-BE49-F238E27FC236}">
-                <a16:creationId xmlns:a16="http://schemas.microsoft.com/office/drawing/2014/main" id="{01D4AAD2-B2A0-45A6-B362-49B46180DD9B}"/>
+                <a16:creationId xmlns:a16="http://schemas.microsoft.com/office/drawing/2014/main" id="{171AF059-C416-444C-B110-834051E72DE4}"/>
               </a:ext>
             </a:extLst>
           </p:cNvPr>
@@ -2590,7 +2998,7 @@
     </p:spTree>
     <p:extLst>
       <p:ext uri="{BB962C8B-B14F-4D97-AF65-F5344CB8AC3E}">
-        <p14:creationId xmlns:p14="http://schemas.microsoft.com/office/powerpoint/2010/main" val="1516958178"/>
+        <p14:creationId xmlns:p14="http://schemas.microsoft.com/office/powerpoint/2010/main" val="763085339"/>
       </p:ext>
     </p:extLst>
   </p:cSld>
@@ -2621,7 +3029,7 @@
           <p:cNvPr id="9" name="">
             <a:extLst xmlns:a="http://schemas.openxmlformats.org/drawingml/2006/main">
               <a:ext uri="{FF2B5EF4-FFF2-40B4-BE49-F238E27FC236}">
-                <a16:creationId xmlns:a16="http://schemas.microsoft.com/office/drawing/2014/main" id="{0B7DB028-E930-459D-AED7-2A98A6CF2B5A}"/>
+                <a16:creationId xmlns:a16="http://schemas.microsoft.com/office/drawing/2014/main" id="{36EB6B84-20EB-4546-8EF1-2038ABAEB6B9}"/>
               </a:ext>
             </a:extLst>
           </p:cNvPr>
@@ -2678,7 +3086,7 @@
           <p:cNvPr id="2" name="">
             <a:extLst xmlns:a="http://schemas.openxmlformats.org/drawingml/2006/main">
               <a:ext uri="{FF2B5EF4-FFF2-40B4-BE49-F238E27FC236}">
-                <a16:creationId xmlns:a16="http://schemas.microsoft.com/office/drawing/2014/main" id="{DF355EB6-E641-4EE9-ADB0-E757FC9B4244}"/>
+                <a16:creationId xmlns:a16="http://schemas.microsoft.com/office/drawing/2014/main" id="{8D621787-4A1D-45AF-8AE5-CC1E473C5B92}"/>
               </a:ext>
             </a:extLst>
           </p:cNvPr>
@@ -2735,7 +3143,7 @@
           <p:cNvPr id="3" name="">
             <a:extLst xmlns:a="http://schemas.openxmlformats.org/drawingml/2006/main">
               <a:ext uri="{FF2B5EF4-FFF2-40B4-BE49-F238E27FC236}">
-                <a16:creationId xmlns:a16="http://schemas.microsoft.com/office/drawing/2014/main" id="{5C4798F2-4387-473C-BD4D-ED4D761E55B5}"/>
+                <a16:creationId xmlns:a16="http://schemas.microsoft.com/office/drawing/2014/main" id="{A8FC4BDE-B726-474A-B4D7-38ACE8B6C2CB}"/>
               </a:ext>
             </a:extLst>
           </p:cNvPr>
@@ -2792,7 +3200,7 @@
           <p:cNvPr id="4" name="">
             <a:extLst xmlns:a="http://schemas.openxmlformats.org/drawingml/2006/main">
               <a:ext uri="{FF2B5EF4-FFF2-40B4-BE49-F238E27FC236}">
-                <a16:creationId xmlns:a16="http://schemas.microsoft.com/office/drawing/2014/main" id="{0ED43CC9-409C-47CE-B6A9-9B4CF34D8213}"/>
+                <a16:creationId xmlns:a16="http://schemas.microsoft.com/office/drawing/2014/main" id="{D6066A8E-0127-4680-B772-6409281D483E}"/>
               </a:ext>
             </a:extLst>
           </p:cNvPr>
@@ -2872,7 +3280,7 @@
           <p:cNvPr id="5" name="">
             <a:extLst xmlns:a="http://schemas.openxmlformats.org/drawingml/2006/main">
               <a:ext uri="{FF2B5EF4-FFF2-40B4-BE49-F238E27FC236}">
-                <a16:creationId xmlns:a16="http://schemas.microsoft.com/office/drawing/2014/main" id="{A63F883F-DCBA-4526-9A9B-E62A757D3B7C}"/>
+                <a16:creationId xmlns:a16="http://schemas.microsoft.com/office/drawing/2014/main" id="{A926D1B0-28DB-4B4B-928F-C5A2A588EFE5}"/>
               </a:ext>
             </a:extLst>
           </p:cNvPr>
@@ -2929,7 +3337,7 @@
           <p:cNvPr id="6" name="">
             <a:extLst xmlns:a="http://schemas.openxmlformats.org/drawingml/2006/main">
               <a:ext uri="{FF2B5EF4-FFF2-40B4-BE49-F238E27FC236}">
-                <a16:creationId xmlns:a16="http://schemas.microsoft.com/office/drawing/2014/main" id="{C4BF19FF-EBAA-48DF-AF41-9AD13E30D698}"/>
+                <a16:creationId xmlns:a16="http://schemas.microsoft.com/office/drawing/2014/main" id="{B96A3867-334C-4E09-9DB1-881A095C604F}"/>
               </a:ext>
             </a:extLst>
           </p:cNvPr>
@@ -3009,7 +3417,7 @@
           <p:cNvPr id="7" name="">
             <a:extLst xmlns:a="http://schemas.openxmlformats.org/drawingml/2006/main">
               <a:ext uri="{FF2B5EF4-FFF2-40B4-BE49-F238E27FC236}">
-                <a16:creationId xmlns:a16="http://schemas.microsoft.com/office/drawing/2014/main" id="{EA1BBB88-916C-4ADA-8309-FB34F4892841}"/>
+                <a16:creationId xmlns:a16="http://schemas.microsoft.com/office/drawing/2014/main" id="{0CAF4D37-9E05-4DF4-B6E2-7483387BCB6F}"/>
               </a:ext>
             </a:extLst>
           </p:cNvPr>
@@ -3066,7 +3474,7 @@
           <p:cNvPr id="8" name="">
             <a:extLst xmlns:a="http://schemas.openxmlformats.org/drawingml/2006/main">
               <a:ext uri="{FF2B5EF4-FFF2-40B4-BE49-F238E27FC236}">
-                <a16:creationId xmlns:a16="http://schemas.microsoft.com/office/drawing/2014/main" id="{38E19988-63EB-4281-BE9D-809BD63FFA98}"/>
+                <a16:creationId xmlns:a16="http://schemas.microsoft.com/office/drawing/2014/main" id="{7C80567E-48E8-4BBF-9A6C-ADDE0E0A3D9B}"/>
               </a:ext>
             </a:extLst>
           </p:cNvPr>
@@ -3121,7 +3529,7 @@
     </p:spTree>
     <p:extLst>
       <p:ext uri="{BB962C8B-B14F-4D97-AF65-F5344CB8AC3E}">
-        <p14:creationId xmlns:p14="http://schemas.microsoft.com/office/powerpoint/2010/main" val="515672302"/>
+        <p14:creationId xmlns:p14="http://schemas.microsoft.com/office/powerpoint/2010/main" val="1764844488"/>
       </p:ext>
     </p:extLst>
   </p:cSld>
@@ -3152,7 +3560,7 @@
           <p:cNvPr id="7" name="">
             <a:extLst xmlns:a="http://schemas.openxmlformats.org/drawingml/2006/main">
               <a:ext uri="{FF2B5EF4-FFF2-40B4-BE49-F238E27FC236}">
-                <a16:creationId xmlns:a16="http://schemas.microsoft.com/office/drawing/2014/main" id="{3E44BD11-4CA9-47AA-8E7C-159CF16993EF}"/>
+                <a16:creationId xmlns:a16="http://schemas.microsoft.com/office/drawing/2014/main" id="{BFBDA219-95F1-44C7-B442-2D2D68F92955}"/>
               </a:ext>
             </a:extLst>
           </p:cNvPr>
@@ -3209,7 +3617,7 @@
           <p:cNvPr id="2" name="">
             <a:extLst xmlns:a="http://schemas.openxmlformats.org/drawingml/2006/main">
               <a:ext uri="{FF2B5EF4-FFF2-40B4-BE49-F238E27FC236}">
-                <a16:creationId xmlns:a16="http://schemas.microsoft.com/office/drawing/2014/main" id="{B48F416E-C526-42A0-ADE8-5ED640E4FCB4}"/>
+                <a16:creationId xmlns:a16="http://schemas.microsoft.com/office/drawing/2014/main" id="{1E92F85E-B5B1-4809-A964-C192FF9FE34F}"/>
               </a:ext>
             </a:extLst>
           </p:cNvPr>
@@ -3266,7 +3674,7 @@
           <p:cNvPr id="3" name="">
             <a:extLst xmlns:a="http://schemas.openxmlformats.org/drawingml/2006/main">
               <a:ext uri="{FF2B5EF4-FFF2-40B4-BE49-F238E27FC236}">
-                <a16:creationId xmlns:a16="http://schemas.microsoft.com/office/drawing/2014/main" id="{B72705C0-5A14-4C06-8DC0-0D510FD7FD33}"/>
+                <a16:creationId xmlns:a16="http://schemas.microsoft.com/office/drawing/2014/main" id="{D00494E4-A63E-402F-9AA4-635F6F464AAA}"/>
               </a:ext>
             </a:extLst>
           </p:cNvPr>
@@ -3323,7 +3731,7 @@
           <p:cNvPr id="4" name="">
             <a:extLst xmlns:a="http://schemas.openxmlformats.org/drawingml/2006/main">
               <a:ext uri="{FF2B5EF4-FFF2-40B4-BE49-F238E27FC236}">
-                <a16:creationId xmlns:a16="http://schemas.microsoft.com/office/drawing/2014/main" id="{28095E29-820C-4EE3-8434-D94FDA161C15}"/>
+                <a16:creationId xmlns:a16="http://schemas.microsoft.com/office/drawing/2014/main" id="{CF167A9F-4D55-4368-AB56-8D4D2F29091E}"/>
               </a:ext>
             </a:extLst>
           </p:cNvPr>
@@ -3380,7 +3788,7 @@
           <p:cNvPr id="5" name="">
             <a:extLst xmlns:a="http://schemas.openxmlformats.org/drawingml/2006/main">
               <a:ext uri="{FF2B5EF4-FFF2-40B4-BE49-F238E27FC236}">
-                <a16:creationId xmlns:a16="http://schemas.microsoft.com/office/drawing/2014/main" id="{7AA552B5-E7D2-4199-A588-88F0EE9E324B}"/>
+                <a16:creationId xmlns:a16="http://schemas.microsoft.com/office/drawing/2014/main" id="{82FB7685-5E3C-4968-9F95-CE2E032EC7E5}"/>
               </a:ext>
             </a:extLst>
           </p:cNvPr>
@@ -3460,7 +3868,7 @@
           <p:cNvPr id="6" name="">
             <a:extLst xmlns:a="http://schemas.openxmlformats.org/drawingml/2006/main">
               <a:ext uri="{FF2B5EF4-FFF2-40B4-BE49-F238E27FC236}">
-                <a16:creationId xmlns:a16="http://schemas.microsoft.com/office/drawing/2014/main" id="{7A99A5A6-753A-4F68-9339-AD43D4CCD14B}"/>
+                <a16:creationId xmlns:a16="http://schemas.microsoft.com/office/drawing/2014/main" id="{D5FEF883-6136-4847-BD36-55D068FFC047}"/>
               </a:ext>
             </a:extLst>
           </p:cNvPr>
@@ -3515,7 +3923,7 @@
     </p:spTree>
     <p:extLst>
       <p:ext uri="{BB962C8B-B14F-4D97-AF65-F5344CB8AC3E}">
-        <p14:creationId xmlns:p14="http://schemas.microsoft.com/office/powerpoint/2010/main" val="787690963"/>
+        <p14:creationId xmlns:p14="http://schemas.microsoft.com/office/powerpoint/2010/main" val="1465757477"/>
       </p:ext>
     </p:extLst>
   </p:cSld>
@@ -3546,7 +3954,7 @@
           <p:cNvPr id="6" name="">
             <a:extLst xmlns:a="http://schemas.openxmlformats.org/drawingml/2006/main">
               <a:ext uri="{FF2B5EF4-FFF2-40B4-BE49-F238E27FC236}">
-                <a16:creationId xmlns:a16="http://schemas.microsoft.com/office/drawing/2014/main" id="{3B1F0ACE-AE1B-462F-9834-B8E6C525EF53}"/>
+                <a16:creationId xmlns:a16="http://schemas.microsoft.com/office/drawing/2014/main" id="{07B4F91E-27C1-4588-9EC9-93071E475420}"/>
               </a:ext>
             </a:extLst>
           </p:cNvPr>
@@ -3603,7 +4011,7 @@
           <p:cNvPr id="2" name="">
             <a:extLst xmlns:a="http://schemas.openxmlformats.org/drawingml/2006/main">
               <a:ext uri="{FF2B5EF4-FFF2-40B4-BE49-F238E27FC236}">
-                <a16:creationId xmlns:a16="http://schemas.microsoft.com/office/drawing/2014/main" id="{9BFAA746-F074-4B80-B9A4-A048C1E293CA}"/>
+                <a16:creationId xmlns:a16="http://schemas.microsoft.com/office/drawing/2014/main" id="{CE8860E1-BD01-4901-B0E0-623B9D24A8E8}"/>
               </a:ext>
             </a:extLst>
           </p:cNvPr>
@@ -3664,13 +4072,13 @@
           <p:nvPr/>
         </p:nvPicPr>
         <p:blipFill>
-          <a:blip xmlns:r="http://schemas.openxmlformats.org/officeDocument/2006/relationships" xmlns:a="http://schemas.openxmlformats.org/drawingml/2006/main" r:embed="R7710bb98cb224056"/>
+          <a:blip xmlns:r="http://schemas.openxmlformats.org/officeDocument/2006/relationships" xmlns:a="http://schemas.openxmlformats.org/drawingml/2006/main" r:embed="Rd13f6054ac494a5b"/>
           <a:stretch xmlns:a="http://schemas.openxmlformats.org/drawingml/2006/main"/>
         </p:blipFill>
         <p:spPr>
           <a:xfrm xmlns:a="http://schemas.openxmlformats.org/drawingml/2006/main">
-            <a:off x="1483302" y="1524000"/>
-            <a:ext cx="5320145" cy="4572000"/>
+            <a:off x="1304310" y="1524000"/>
+            <a:ext cx="5678129" cy="4572000"/>
           </a:xfrm>
           <a:prstGeom xmlns:a="http://schemas.openxmlformats.org/drawingml/2006/main" prst="rect">
             <a:avLst/>
@@ -3682,7 +4090,7 @@
           <p:cNvPr id="4" name="">
             <a:extLst xmlns:a="http://schemas.openxmlformats.org/drawingml/2006/main">
               <a:ext uri="{FF2B5EF4-FFF2-40B4-BE49-F238E27FC236}">
-                <a16:creationId xmlns:a16="http://schemas.microsoft.com/office/drawing/2014/main" id="{BCD94F7F-527F-4D40-B0D0-28A9F9B79C5A}"/>
+                <a16:creationId xmlns:a16="http://schemas.microsoft.com/office/drawing/2014/main" id="{81A6546F-459F-4B37-9881-3B26B8C0CEA8}"/>
               </a:ext>
             </a:extLst>
           </p:cNvPr>
@@ -3693,8 +4101,8 @@
         </p:nvSpPr>
         <p:spPr>
           <a:xfrm xmlns:a="http://schemas.openxmlformats.org/drawingml/2006/main">
-            <a:off x="8096250" y="2095500"/>
-            <a:ext cx="3429000" cy="714375"/>
+            <a:off x="8048625" y="2095500"/>
+            <a:ext cx="3524250" cy="1095375"/>
           </a:xfrm>
           <a:prstGeom xmlns:a="http://schemas.openxmlformats.org/drawingml/2006/main" prst="rect">
             <a:avLst/>
@@ -3711,7 +4119,7 @@
           <a:lstStyle xmlns:a="http://schemas.openxmlformats.org/drawingml/2006/main"/>
           <a:p xmlns:a="http://schemas.openxmlformats.org/drawingml/2006/main">
             <a:pPr>
-              <a:defRPr sz="2850" b="1">
+              <a:defRPr sz="2625" b="1">
                 <a:solidFill>
                   <a:srgbClr val="006B68"/>
                 </a:solidFill>
@@ -3721,7 +4129,7 @@
               </a:defRPr>
             </a:pPr>
             <a:r>
-              <a:rPr sz="2850" b="1">
+              <a:rPr sz="2625" b="1">
                 <a:solidFill>
                   <a:srgbClr val="006B68"/>
                 </a:solidFill>
@@ -3729,7 +4137,7 @@
                 <a:ea typeface="Calibri"/>
                 <a:cs typeface="Calibri"/>
               </a:rPr>
-              <a:t>127,8 unidades</a:t>
+              <a:t>113,7 ± 8,1 unidades</a:t>
             </a:r>
           </a:p>
         </p:txBody>
@@ -3739,7 +4147,7 @@
           <p:cNvPr id="5" name="">
             <a:extLst xmlns:a="http://schemas.openxmlformats.org/drawingml/2006/main">
               <a:ext uri="{FF2B5EF4-FFF2-40B4-BE49-F238E27FC236}">
-                <a16:creationId xmlns:a16="http://schemas.microsoft.com/office/drawing/2014/main" id="{2344C890-8500-4239-B910-4AC1D64250EA}"/>
+                <a16:creationId xmlns:a16="http://schemas.microsoft.com/office/drawing/2014/main" id="{5588352A-CB9F-4222-93DC-52C6D9C9A83F}"/>
               </a:ext>
             </a:extLst>
           </p:cNvPr>
@@ -3750,8 +4158,8 @@
         </p:nvSpPr>
         <p:spPr>
           <a:xfrm xmlns:a="http://schemas.openxmlformats.org/drawingml/2006/main">
-            <a:off x="8096250" y="3190875"/>
-            <a:ext cx="3429000" cy="2095500"/>
+            <a:off x="8048625" y="3286125"/>
+            <a:ext cx="3429000" cy="2381250"/>
           </a:xfrm>
           <a:prstGeom xmlns:a="http://schemas.openxmlformats.org/drawingml/2006/main" prst="rect">
             <a:avLst/>
@@ -3768,25 +4176,48 @@
           <a:lstStyle xmlns:a="http://schemas.openxmlformats.org/drawingml/2006/main"/>
           <a:p xmlns:a="http://schemas.openxmlformats.org/drawingml/2006/main">
             <a:pPr>
-              <a:defRPr sz="2025" b="0">
-                <a:solidFill>
-                  <a:srgbClr val="173345"/>
-                </a:solidFill>
-                <a:latin typeface="Calibri"/>
-                <a:ea typeface="Calibri"/>
-                <a:cs typeface="Calibri"/>
-              </a:defRPr>
-            </a:pPr>
-            <a:r>
-              <a:rPr sz="2025" b="0">
-                <a:solidFill>
-                  <a:srgbClr val="173345"/>
-                </a:solidFill>
-                <a:latin typeface="Calibri"/>
-                <a:ea typeface="Calibri"/>
-                <a:cs typeface="Calibri"/>
-              </a:rPr>
-              <a:t>Predicción de demostración</a:t>
+              <a:defRPr sz="1800" b="0">
+                <a:solidFill>
+                  <a:srgbClr val="173345"/>
+                </a:solidFill>
+                <a:latin typeface="Calibri"/>
+                <a:ea typeface="Calibri"/>
+                <a:cs typeface="Calibri"/>
+              </a:defRPr>
+            </a:pPr>
+            <a:r>
+              <a:rPr sz="1800" b="0">
+                <a:solidFill>
+                  <a:srgbClr val="173345"/>
+                </a:solidFill>
+                <a:latin typeface="Calibri"/>
+                <a:ea typeface="Calibri"/>
+                <a:cs typeface="Calibri"/>
+              </a:rPr>
+              <a:t>Escenario sintético</a:t>
+            </a:r>
+          </a:p>
+          <a:p xmlns:a="http://schemas.openxmlformats.org/drawingml/2006/main">
+            <a:pPr>
+              <a:defRPr sz="1800" b="0">
+                <a:solidFill>
+                  <a:srgbClr val="173345"/>
+                </a:solidFill>
+                <a:latin typeface="Calibri"/>
+                <a:ea typeface="Calibri"/>
+                <a:cs typeface="Calibri"/>
+              </a:defRPr>
+            </a:pPr>
+            <a:r>
+              <a:rPr sz="1800" b="0">
+                <a:solidFill>
+                  <a:srgbClr val="173345"/>
+                </a:solidFill>
+                <a:latin typeface="Calibri"/>
+                <a:ea typeface="Calibri"/>
+                <a:cs typeface="Calibri"/>
+              </a:rPr>
+              <a:t>RMSE de test: referencia de error, no intervalo de confianza.</a:t>
             </a:r>
           </a:p>
           <a:p xmlns:a="http://schemas.openxmlformats.org/drawingml/2006/main">
@@ -3796,25 +4227,25 @@
           </a:p>
           <a:p xmlns:a="http://schemas.openxmlformats.org/drawingml/2006/main">
             <a:pPr>
-              <a:defRPr sz="2025" b="0">
-                <a:solidFill>
-                  <a:srgbClr val="173345"/>
-                </a:solidFill>
-                <a:latin typeface="Calibri"/>
-                <a:ea typeface="Calibri"/>
-                <a:cs typeface="Calibri"/>
-              </a:defRPr>
-            </a:pPr>
-            <a:r>
-              <a:rPr sz="2025" b="0">
-                <a:solidFill>
-                  <a:srgbClr val="173345"/>
-                </a:solidFill>
-                <a:latin typeface="Calibri"/>
-                <a:ea typeface="Calibri"/>
-                <a:cs typeface="Calibri"/>
-              </a:rPr>
-              <a:t>El formulario conserva las entradas y muestra límites de uso.</a:t>
+              <a:defRPr sz="1800" b="0">
+                <a:solidFill>
+                  <a:srgbClr val="173345"/>
+                </a:solidFill>
+                <a:latin typeface="Calibri"/>
+                <a:ea typeface="Calibri"/>
+                <a:cs typeface="Calibri"/>
+              </a:defRPr>
+            </a:pPr>
+            <a:r>
+              <a:rPr sz="1800" b="0">
+                <a:solidFill>
+                  <a:srgbClr val="173345"/>
+                </a:solidFill>
+                <a:latin typeface="Calibri"/>
+                <a:ea typeface="Calibri"/>
+                <a:cs typeface="Calibri"/>
+              </a:rPr>
+              <a:t>La recomendación compara con el promedio reciente de la ruta.</a:t>
             </a:r>
           </a:p>
         </p:txBody>
@@ -3822,7 +4253,7 @@
     </p:spTree>
     <p:extLst>
       <p:ext uri="{BB962C8B-B14F-4D97-AF65-F5344CB8AC3E}">
-        <p14:creationId xmlns:p14="http://schemas.microsoft.com/office/powerpoint/2010/main" val="184059509"/>
+        <p14:creationId xmlns:p14="http://schemas.microsoft.com/office/powerpoint/2010/main" val="29396863"/>
       </p:ext>
     </p:extLst>
   </p:cSld>
@@ -3853,7 +4284,7 @@
           <p:cNvPr id="6" name="">
             <a:extLst xmlns:a="http://schemas.openxmlformats.org/drawingml/2006/main">
               <a:ext uri="{FF2B5EF4-FFF2-40B4-BE49-F238E27FC236}">
-                <a16:creationId xmlns:a16="http://schemas.microsoft.com/office/drawing/2014/main" id="{E6A621DB-0947-461C-B5C0-89C66712CD9A}"/>
+                <a16:creationId xmlns:a16="http://schemas.microsoft.com/office/drawing/2014/main" id="{9137E916-42CA-4AF6-971C-D91FA2F7D396}"/>
               </a:ext>
             </a:extLst>
           </p:cNvPr>
@@ -3910,7 +4341,7 @@
           <p:cNvPr id="2" name="">
             <a:extLst xmlns:a="http://schemas.openxmlformats.org/drawingml/2006/main">
               <a:ext uri="{FF2B5EF4-FFF2-40B4-BE49-F238E27FC236}">
-                <a16:creationId xmlns:a16="http://schemas.microsoft.com/office/drawing/2014/main" id="{1A3D36AF-4D4D-4B32-B3A2-D41568960292}"/>
+                <a16:creationId xmlns:a16="http://schemas.microsoft.com/office/drawing/2014/main" id="{372798DB-87A6-46F0-ACBA-A3761B15E643}"/>
               </a:ext>
             </a:extLst>
           </p:cNvPr>
@@ -3974,7 +4405,7 @@
         </p:xfrm>
         <a:graphic xmlns:a="http://schemas.openxmlformats.org/drawingml/2006/main">
           <a:graphicData uri="http://schemas.openxmlformats.org/drawingml/2006/chart">
-            <c:chart xmlns:r="http://schemas.openxmlformats.org/officeDocument/2006/relationships" xmlns:c="http://schemas.openxmlformats.org/drawingml/2006/chart" r:id="R5a5b466054464d88"/>
+            <c:chart xmlns:r="http://schemas.openxmlformats.org/officeDocument/2006/relationships" xmlns:c="http://schemas.openxmlformats.org/drawingml/2006/chart" r:id="Rff01decb0bbd4101"/>
           </a:graphicData>
         </a:graphic>
       </p:graphicFrame>
@@ -3983,7 +4414,7 @@
           <p:cNvPr id="4" name="">
             <a:extLst xmlns:a="http://schemas.openxmlformats.org/drawingml/2006/main">
               <a:ext uri="{FF2B5EF4-FFF2-40B4-BE49-F238E27FC236}">
-                <a16:creationId xmlns:a16="http://schemas.microsoft.com/office/drawing/2014/main" id="{4AFD35BF-B7BE-4481-BA99-334D5BFC1BB3}"/>
+                <a16:creationId xmlns:a16="http://schemas.microsoft.com/office/drawing/2014/main" id="{A22C5EE3-6870-4EC1-AEAF-CED10898768D}"/>
               </a:ext>
             </a:extLst>
           </p:cNvPr>
@@ -4086,7 +4517,7 @@
           <p:cNvPr id="5" name="">
             <a:extLst xmlns:a="http://schemas.openxmlformats.org/drawingml/2006/main">
               <a:ext uri="{FF2B5EF4-FFF2-40B4-BE49-F238E27FC236}">
-                <a16:creationId xmlns:a16="http://schemas.microsoft.com/office/drawing/2014/main" id="{AE1E5F3B-9316-417F-8151-6A2D6D28CB63}"/>
+                <a16:creationId xmlns:a16="http://schemas.microsoft.com/office/drawing/2014/main" id="{6DBA9133-3511-4F41-B647-4E2D7E2E1865}"/>
               </a:ext>
             </a:extLst>
           </p:cNvPr>
@@ -4164,7 +4595,7 @@
     </p:spTree>
     <p:extLst>
       <p:ext uri="{BB962C8B-B14F-4D97-AF65-F5344CB8AC3E}">
-        <p14:creationId xmlns:p14="http://schemas.microsoft.com/office/powerpoint/2010/main" val="847729964"/>
+        <p14:creationId xmlns:p14="http://schemas.microsoft.com/office/powerpoint/2010/main" val="1724936031"/>
       </p:ext>
     </p:extLst>
   </p:cSld>
@@ -4192,10 +4623,10 @@
       </p:grpSpPr>
       <p:sp>
         <p:nvSpPr>
-          <p:cNvPr id="7" name="">
+          <p:cNvPr id="6" name="">
             <a:extLst xmlns:a="http://schemas.openxmlformats.org/drawingml/2006/main">
               <a:ext uri="{FF2B5EF4-FFF2-40B4-BE49-F238E27FC236}">
-                <a16:creationId xmlns:a16="http://schemas.microsoft.com/office/drawing/2014/main" id="{266228EA-0DD9-447D-88A2-25CC0B0C541F}"/>
+                <a16:creationId xmlns:a16="http://schemas.microsoft.com/office/drawing/2014/main" id="{FD94D0D0-C41B-438D-8EBB-53D52CFC6A66}"/>
               </a:ext>
             </a:extLst>
           </p:cNvPr>
@@ -4242,7 +4673,7 @@
                 <a:ea typeface="Calibri"/>
                 <a:cs typeface="Calibri"/>
               </a:rPr>
-              <a:t>Pruebas y carga local</a:t>
+              <a:t>Documentación y prueba de la API</a:t>
             </a:r>
           </a:p>
         </p:txBody>
@@ -4252,7 +4683,7 @@
           <p:cNvPr id="2" name="">
             <a:extLst xmlns:a="http://schemas.openxmlformats.org/drawingml/2006/main">
               <a:ext uri="{FF2B5EF4-FFF2-40B4-BE49-F238E27FC236}">
-                <a16:creationId xmlns:a16="http://schemas.microsoft.com/office/drawing/2014/main" id="{C6401B69-FB70-4516-ABED-9D04F66A54FF}"/>
+                <a16:creationId xmlns:a16="http://schemas.microsoft.com/office/drawing/2014/main" id="{4BD82510-CD87-4BD0-8F76-3B85B76B93D8}"/>
               </a:ext>
             </a:extLst>
           </p:cNvPr>
@@ -4304,12 +4735,34 @@
           </a:p>
         </p:txBody>
       </p:sp>
-      <p:sp>
-        <p:nvSpPr>
-          <p:cNvPr id="3" name="">
+      <p:pic>
+        <p:nvPicPr>
+          <p:cNvPr id="8" name=""/>
+          <p:cNvPicPr>
+            <a:picLocks xmlns:a="http://schemas.openxmlformats.org/drawingml/2006/main" noChangeAspect="1"/>
+          </p:cNvPicPr>
+          <p:nvPr/>
+        </p:nvPicPr>
+        <p:blipFill>
+          <a:blip xmlns:r="http://schemas.openxmlformats.org/officeDocument/2006/relationships" xmlns:a="http://schemas.openxmlformats.org/drawingml/2006/main" r:embed="Re368e7aab35c4259"/>
+          <a:stretch xmlns:a="http://schemas.openxmlformats.org/drawingml/2006/main"/>
+        </p:blipFill>
+        <p:spPr>
+          <a:xfrm xmlns:a="http://schemas.openxmlformats.org/drawingml/2006/main">
+            <a:off x="1847069" y="1476375"/>
+            <a:ext cx="3592486" cy="4572000"/>
+          </a:xfrm>
+          <a:prstGeom xmlns:a="http://schemas.openxmlformats.org/drawingml/2006/main" prst="rect">
+            <a:avLst/>
+          </a:prstGeom>
+        </p:spPr>
+      </p:pic>
+      <p:sp>
+        <p:nvSpPr>
+          <p:cNvPr id="4" name="">
             <a:extLst xmlns:a="http://schemas.openxmlformats.org/drawingml/2006/main">
               <a:ext uri="{FF2B5EF4-FFF2-40B4-BE49-F238E27FC236}">
-                <a16:creationId xmlns:a16="http://schemas.microsoft.com/office/drawing/2014/main" id="{85F8A98A-C50D-4D54-B09B-BB2103A754A8}"/>
+                <a16:creationId xmlns:a16="http://schemas.microsoft.com/office/drawing/2014/main" id="{A2E992B5-FB55-4877-9785-E0CA1C231DFF}"/>
               </a:ext>
             </a:extLst>
           </p:cNvPr>
@@ -4320,8 +4773,8 @@
         </p:nvSpPr>
         <p:spPr>
           <a:xfrm xmlns:a="http://schemas.openxmlformats.org/drawingml/2006/main">
-            <a:off x="619125" y="1714500"/>
-            <a:ext cx="10477500" cy="762000"/>
+            <a:off x="7143750" y="1952625"/>
+            <a:ext cx="3810000" cy="762000"/>
           </a:xfrm>
           <a:prstGeom xmlns:a="http://schemas.openxmlformats.org/drawingml/2006/main" prst="rect">
             <a:avLst/>
@@ -4338,7 +4791,7 @@
           <a:lstStyle xmlns:a="http://schemas.openxmlformats.org/drawingml/2006/main"/>
           <a:p xmlns:a="http://schemas.openxmlformats.org/drawingml/2006/main">
             <a:pPr>
-              <a:defRPr sz="3300" b="1">
+              <a:defRPr sz="3225" b="1">
                 <a:solidFill>
                   <a:srgbClr val="006B68"/>
                 </a:solidFill>
@@ -4348,7 +4801,7 @@
               </a:defRPr>
             </a:pPr>
             <a:r>
-              <a:rPr sz="3300" b="1">
+              <a:rPr sz="3225" b="1">
                 <a:solidFill>
                   <a:srgbClr val="006B68"/>
                 </a:solidFill>
@@ -4356,17 +4809,17 @@
                 <a:ea typeface="Calibri"/>
                 <a:cs typeface="Calibri"/>
               </a:rPr>
-              <a:t>16 pruebas aprobadas</a:t>
-            </a:r>
-          </a:p>
-        </p:txBody>
-      </p:sp>
-      <p:sp>
-        <p:nvSpPr>
-          <p:cNvPr id="4" name="">
+              <a:t>/docs</a:t>
+            </a:r>
+          </a:p>
+        </p:txBody>
+      </p:sp>
+      <p:sp>
+        <p:nvSpPr>
+          <p:cNvPr id="5" name="">
             <a:extLst xmlns:a="http://schemas.openxmlformats.org/drawingml/2006/main">
               <a:ext uri="{FF2B5EF4-FFF2-40B4-BE49-F238E27FC236}">
-                <a16:creationId xmlns:a16="http://schemas.microsoft.com/office/drawing/2014/main" id="{C692EABB-922A-4C1F-96BE-6F09C03F0D89}"/>
+                <a16:creationId xmlns:a16="http://schemas.microsoft.com/office/drawing/2014/main" id="{42CA5E13-173E-4F92-9250-EE3BD34439D4}"/>
               </a:ext>
             </a:extLst>
           </p:cNvPr>
@@ -4377,8 +4830,8 @@
         </p:nvSpPr>
         <p:spPr>
           <a:xfrm xmlns:a="http://schemas.openxmlformats.org/drawingml/2006/main">
-            <a:off x="619125" y="2667000"/>
-            <a:ext cx="10477500" cy="857250"/>
+            <a:off x="7143750" y="3000375"/>
+            <a:ext cx="4000500" cy="2857500"/>
           </a:xfrm>
           <a:prstGeom xmlns:a="http://schemas.openxmlformats.org/drawingml/2006/main" prst="rect">
             <a:avLst/>
@@ -4395,231 +4848,99 @@
           <a:lstStyle xmlns:a="http://schemas.openxmlformats.org/drawingml/2006/main"/>
           <a:p xmlns:a="http://schemas.openxmlformats.org/drawingml/2006/main">
             <a:pPr>
-              <a:defRPr sz="2175" b="0">
-                <a:solidFill>
-                  <a:srgbClr val="173345"/>
-                </a:solidFill>
-                <a:latin typeface="Calibri"/>
-                <a:ea typeface="Calibri"/>
-                <a:cs typeface="Calibri"/>
-              </a:defRPr>
-            </a:pPr>
-            <a:r>
-              <a:rPr sz="2175" b="0">
-                <a:solidFill>
-                  <a:srgbClr val="173345"/>
-                </a:solidFill>
-                <a:latin typeface="Calibri"/>
-                <a:ea typeface="Calibri"/>
-                <a:cs typeface="Calibri"/>
-              </a:rPr>
-              <a:t>Predicciones, entradas inválidas, integración y fallos del servicio</a:t>
-            </a:r>
-          </a:p>
-        </p:txBody>
-      </p:sp>
-      <p:sp>
-        <p:nvSpPr>
-          <p:cNvPr id="5" name="">
-            <a:extLst xmlns:a="http://schemas.openxmlformats.org/drawingml/2006/main">
-              <a:ext uri="{FF2B5EF4-FFF2-40B4-BE49-F238E27FC236}">
-                <a16:creationId xmlns:a16="http://schemas.microsoft.com/office/drawing/2014/main" id="{D754BD5C-B4D7-47D9-B2E9-E05BB40777D8}"/>
-              </a:ext>
-            </a:extLst>
-          </p:cNvPr>
-          <p:cNvSpPr>
-            <a:spLocks xmlns:a="http://schemas.openxmlformats.org/drawingml/2006/main" noGrp="1"/>
-          </p:cNvSpPr>
-          <p:nvPr/>
-        </p:nvSpPr>
-        <p:spPr>
-          <a:xfrm xmlns:a="http://schemas.openxmlformats.org/drawingml/2006/main">
-            <a:off x="619125" y="3810000"/>
-            <a:ext cx="6667500" cy="1809750"/>
-          </a:xfrm>
-          <a:prstGeom xmlns:a="http://schemas.openxmlformats.org/drawingml/2006/main" prst="rect">
-            <a:avLst/>
-          </a:prstGeom>
-          <a:noFill xmlns:a="http://schemas.openxmlformats.org/drawingml/2006/main"/>
-          <a:ln xmlns:a="http://schemas.openxmlformats.org/drawingml/2006/main" w="0">
-            <a:noFill/>
-          </a:ln>
-        </p:spPr>
-        <p:txBody>
-          <a:bodyPr xmlns:a="http://schemas.openxmlformats.org/drawingml/2006/main">
-            <a:noAutofit/>
-          </a:bodyPr>
-          <a:lstStyle xmlns:a="http://schemas.openxmlformats.org/drawingml/2006/main"/>
-          <a:p xmlns:a="http://schemas.openxmlformats.org/drawingml/2006/main">
-            <a:pPr>
-              <a:defRPr sz="2400" b="0">
-                <a:solidFill>
-                  <a:srgbClr val="173345"/>
-                </a:solidFill>
-                <a:latin typeface="Calibri"/>
-                <a:ea typeface="Calibri"/>
-                <a:cs typeface="Calibri"/>
-              </a:defRPr>
-            </a:pPr>
-            <a:r>
-              <a:rPr sz="2400" b="0">
-                <a:solidFill>
-                  <a:srgbClr val="173345"/>
-                </a:solidFill>
-                <a:latin typeface="Calibri"/>
-                <a:ea typeface="Calibri"/>
-                <a:cs typeface="Calibri"/>
-              </a:rPr>
-              <a:t>API: p95 52.2 ms</a:t>
-            </a:r>
-          </a:p>
-          <a:p xmlns:a="http://schemas.openxmlformats.org/drawingml/2006/main">
-            <a:pPr>
-              <a:defRPr sz="2400" b="0">
-                <a:solidFill>
-                  <a:srgbClr val="173345"/>
-                </a:solidFill>
-                <a:latin typeface="Calibri"/>
-                <a:ea typeface="Calibri"/>
-                <a:cs typeface="Calibri"/>
-              </a:defRPr>
-            </a:pPr>
-            <a:r>
-              <a:rPr sz="2400" b="0">
-                <a:solidFill>
-                  <a:srgbClr val="173345"/>
-                </a:solidFill>
-                <a:latin typeface="Calibri"/>
-                <a:ea typeface="Calibri"/>
-                <a:cs typeface="Calibri"/>
-              </a:rPr>
-              <a:t>Web y API: p95 96.3 ms</a:t>
-            </a:r>
-          </a:p>
-          <a:p xmlns:a="http://schemas.openxmlformats.org/drawingml/2006/main">
-            <a:pPr>
-              <a:defRPr sz="2400" b="0">
-                <a:solidFill>
-                  <a:srgbClr val="173345"/>
-                </a:solidFill>
-                <a:latin typeface="Calibri"/>
-                <a:ea typeface="Calibri"/>
-                <a:cs typeface="Calibri"/>
-              </a:defRPr>
-            </a:pPr>
-            <a:r>
-              <a:rPr sz="2400" b="0">
-                <a:solidFill>
-                  <a:srgbClr val="173345"/>
-                </a:solidFill>
-                <a:latin typeface="Calibri"/>
-                <a:ea typeface="Calibri"/>
-                <a:cs typeface="Calibri"/>
-              </a:rPr>
-              <a:t>0 errores en ambos escenarios</a:t>
-            </a:r>
-          </a:p>
-        </p:txBody>
-      </p:sp>
-      <p:sp>
-        <p:nvSpPr>
-          <p:cNvPr id="6" name="">
-            <a:extLst xmlns:a="http://schemas.openxmlformats.org/drawingml/2006/main">
-              <a:ext uri="{FF2B5EF4-FFF2-40B4-BE49-F238E27FC236}">
-                <a16:creationId xmlns:a16="http://schemas.microsoft.com/office/drawing/2014/main" id="{B373439E-939B-45C3-B0E0-17927E362F88}"/>
-              </a:ext>
-            </a:extLst>
-          </p:cNvPr>
-          <p:cNvSpPr>
-            <a:spLocks xmlns:a="http://schemas.openxmlformats.org/drawingml/2006/main" noGrp="1"/>
-          </p:cNvSpPr>
-          <p:nvPr/>
-        </p:nvSpPr>
-        <p:spPr>
-          <a:xfrm xmlns:a="http://schemas.openxmlformats.org/drawingml/2006/main">
-            <a:off x="8286750" y="3952875"/>
-            <a:ext cx="3143250" cy="1619250"/>
-          </a:xfrm>
-          <a:prstGeom xmlns:a="http://schemas.openxmlformats.org/drawingml/2006/main" prst="rect">
-            <a:avLst/>
-          </a:prstGeom>
-          <a:noFill xmlns:a="http://schemas.openxmlformats.org/drawingml/2006/main"/>
-          <a:ln xmlns:a="http://schemas.openxmlformats.org/drawingml/2006/main" w="0">
-            <a:noFill/>
-          </a:ln>
-        </p:spPr>
-        <p:txBody>
-          <a:bodyPr xmlns:a="http://schemas.openxmlformats.org/drawingml/2006/main">
-            <a:noAutofit/>
-          </a:bodyPr>
-          <a:lstStyle xmlns:a="http://schemas.openxmlformats.org/drawingml/2006/main"/>
-          <a:p xmlns:a="http://schemas.openxmlformats.org/drawingml/2006/main">
-            <a:pPr>
-              <a:defRPr sz="2250" b="0">
-                <a:solidFill>
-                  <a:srgbClr val="173345"/>
-                </a:solidFill>
-                <a:latin typeface="Calibri"/>
-                <a:ea typeface="Calibri"/>
-                <a:cs typeface="Calibri"/>
-              </a:defRPr>
-            </a:pPr>
-            <a:r>
-              <a:rPr sz="2250" b="0">
-                <a:solidFill>
-                  <a:srgbClr val="173345"/>
-                </a:solidFill>
-                <a:latin typeface="Calibri"/>
-                <a:ea typeface="Calibri"/>
-                <a:cs typeface="Calibri"/>
-              </a:rPr>
-              <a:t>100 solicitudes</a:t>
-            </a:r>
-          </a:p>
-          <a:p xmlns:a="http://schemas.openxmlformats.org/drawingml/2006/main">
-            <a:pPr>
-              <a:defRPr sz="2250" b="0">
-                <a:solidFill>
-                  <a:srgbClr val="173345"/>
-                </a:solidFill>
-                <a:latin typeface="Calibri"/>
-                <a:ea typeface="Calibri"/>
-                <a:cs typeface="Calibri"/>
-              </a:defRPr>
-            </a:pPr>
-            <a:r>
-              <a:rPr sz="2250" b="0">
-                <a:solidFill>
-                  <a:srgbClr val="173345"/>
-                </a:solidFill>
-                <a:latin typeface="Calibri"/>
-                <a:ea typeface="Calibri"/>
-                <a:cs typeface="Calibri"/>
-              </a:rPr>
-              <a:t>10 concurrentes</a:t>
-            </a:r>
-          </a:p>
-          <a:p xmlns:a="http://schemas.openxmlformats.org/drawingml/2006/main">
-            <a:pPr>
-              <a:defRPr sz="2250" b="0">
-                <a:solidFill>
-                  <a:srgbClr val="173345"/>
-                </a:solidFill>
-                <a:latin typeface="Calibri"/>
-                <a:ea typeface="Calibri"/>
-                <a:cs typeface="Calibri"/>
-              </a:defRPr>
-            </a:pPr>
-            <a:r>
-              <a:rPr sz="2250" b="0">
-                <a:solidFill>
-                  <a:srgbClr val="173345"/>
-                </a:solidFill>
-                <a:latin typeface="Calibri"/>
-                <a:ea typeface="Calibri"/>
-                <a:cs typeface="Calibri"/>
-              </a:rPr>
-              <a:t>por escenario</a:t>
+              <a:defRPr sz="2025" b="0">
+                <a:solidFill>
+                  <a:srgbClr val="173345"/>
+                </a:solidFill>
+                <a:latin typeface="Calibri"/>
+                <a:ea typeface="Calibri"/>
+                <a:cs typeface="Calibri"/>
+              </a:defRPr>
+            </a:pPr>
+            <a:r>
+              <a:rPr sz="2025" b="0">
+                <a:solidFill>
+                  <a:srgbClr val="173345"/>
+                </a:solidFill>
+                <a:latin typeface="Calibri"/>
+                <a:ea typeface="Calibri"/>
+                <a:cs typeface="Calibri"/>
+              </a:rPr>
+              <a:t>Prueba interactiva de POST /predict</a:t>
+            </a:r>
+          </a:p>
+          <a:p xmlns:a="http://schemas.openxmlformats.org/drawingml/2006/main">
+            <a:r>
+              <a:t/>
+            </a:r>
+          </a:p>
+          <a:p xmlns:a="http://schemas.openxmlformats.org/drawingml/2006/main">
+            <a:pPr>
+              <a:defRPr sz="2025" b="0">
+                <a:solidFill>
+                  <a:srgbClr val="173345"/>
+                </a:solidFill>
+                <a:latin typeface="Calibri"/>
+                <a:ea typeface="Calibri"/>
+                <a:cs typeface="Calibri"/>
+              </a:defRPr>
+            </a:pPr>
+            <a:r>
+              <a:rPr sz="2025" b="0">
+                <a:solidFill>
+                  <a:srgbClr val="173345"/>
+                </a:solidFill>
+                <a:latin typeface="Calibri"/>
+                <a:ea typeface="Calibri"/>
+                <a:cs typeface="Calibri"/>
+              </a:rPr>
+              <a:t>Validación de entradas: 422</a:t>
+            </a:r>
+          </a:p>
+          <a:p xmlns:a="http://schemas.openxmlformats.org/drawingml/2006/main">
+            <a:pPr>
+              <a:defRPr sz="2025" b="0">
+                <a:solidFill>
+                  <a:srgbClr val="173345"/>
+                </a:solidFill>
+                <a:latin typeface="Calibri"/>
+                <a:ea typeface="Calibri"/>
+                <a:cs typeface="Calibri"/>
+              </a:defRPr>
+            </a:pPr>
+            <a:r>
+              <a:rPr sz="2025" b="0">
+                <a:solidFill>
+                  <a:srgbClr val="173345"/>
+                </a:solidFill>
+                <a:latin typeface="Calibri"/>
+                <a:ea typeface="Calibri"/>
+                <a:cs typeface="Calibri"/>
+              </a:rPr>
+              <a:t>Modelo no disponible: 503</a:t>
+            </a:r>
+          </a:p>
+          <a:p xmlns:a="http://schemas.openxmlformats.org/drawingml/2006/main">
+            <a:pPr>
+              <a:defRPr sz="2025" b="0">
+                <a:solidFill>
+                  <a:srgbClr val="173345"/>
+                </a:solidFill>
+                <a:latin typeface="Calibri"/>
+                <a:ea typeface="Calibri"/>
+                <a:cs typeface="Calibri"/>
+              </a:defRPr>
+            </a:pPr>
+            <a:r>
+              <a:rPr sz="2025" b="0">
+                <a:solidFill>
+                  <a:srgbClr val="173345"/>
+                </a:solidFill>
+                <a:latin typeface="Calibri"/>
+                <a:ea typeface="Calibri"/>
+                <a:cs typeface="Calibri"/>
+              </a:rPr>
+              <a:t>Esquema: /openapi.json</a:t>
             </a:r>
           </a:p>
         </p:txBody>
@@ -4627,7 +4948,7 @@
     </p:spTree>
     <p:extLst>
       <p:ext uri="{BB962C8B-B14F-4D97-AF65-F5344CB8AC3E}">
-        <p14:creationId xmlns:p14="http://schemas.microsoft.com/office/powerpoint/2010/main" val="1295452393"/>
+        <p14:creationId xmlns:p14="http://schemas.microsoft.com/office/powerpoint/2010/main" val="2010334496"/>
       </p:ext>
     </p:extLst>
   </p:cSld>
@@ -4658,7 +4979,7 @@
           <p:cNvPr id="7" name="">
             <a:extLst xmlns:a="http://schemas.openxmlformats.org/drawingml/2006/main">
               <a:ext uri="{FF2B5EF4-FFF2-40B4-BE49-F238E27FC236}">
-                <a16:creationId xmlns:a16="http://schemas.microsoft.com/office/drawing/2014/main" id="{9FDBBF79-ED15-4774-A49B-7E76BC52BE4C}"/>
+                <a16:creationId xmlns:a16="http://schemas.microsoft.com/office/drawing/2014/main" id="{ECFF8C2C-0E57-4E4F-A7F9-670543A33986}"/>
               </a:ext>
             </a:extLst>
           </p:cNvPr>
@@ -4705,7 +5026,7 @@
                 <a:ea typeface="Calibri"/>
                 <a:cs typeface="Calibri"/>
               </a:rPr>
-              <a:t>Validación pendiente</a:t>
+              <a:t>Pruebas y carga local</a:t>
             </a:r>
           </a:p>
         </p:txBody>
@@ -4715,7 +5036,7 @@
           <p:cNvPr id="2" name="">
             <a:extLst xmlns:a="http://schemas.openxmlformats.org/drawingml/2006/main">
               <a:ext uri="{FF2B5EF4-FFF2-40B4-BE49-F238E27FC236}">
-                <a16:creationId xmlns:a16="http://schemas.microsoft.com/office/drawing/2014/main" id="{B899E0B6-3256-409F-94E8-6476C864E2C7}"/>
+                <a16:creationId xmlns:a16="http://schemas.microsoft.com/office/drawing/2014/main" id="{CC6F3E9F-0886-4652-A956-10F6FB5DE71E}"/>
               </a:ext>
             </a:extLst>
           </p:cNvPr>
@@ -4772,7 +5093,7 @@
           <p:cNvPr id="3" name="">
             <a:extLst xmlns:a="http://schemas.openxmlformats.org/drawingml/2006/main">
               <a:ext uri="{FF2B5EF4-FFF2-40B4-BE49-F238E27FC236}">
-                <a16:creationId xmlns:a16="http://schemas.microsoft.com/office/drawing/2014/main" id="{86E19B7A-FF70-4BC5-998A-C9E26D8C3FE7}"/>
+                <a16:creationId xmlns:a16="http://schemas.microsoft.com/office/drawing/2014/main" id="{5D9E3F0B-3D30-4C75-817D-F39AEECB90D4}"/>
               </a:ext>
             </a:extLst>
           </p:cNvPr>
@@ -4784,7 +5105,7 @@
         <p:spPr>
           <a:xfrm xmlns:a="http://schemas.openxmlformats.org/drawingml/2006/main">
             <a:off x="619125" y="1714500"/>
-            <a:ext cx="5238750" cy="666750"/>
+            <a:ext cx="10477500" cy="762000"/>
           </a:xfrm>
           <a:prstGeom xmlns:a="http://schemas.openxmlformats.org/drawingml/2006/main" prst="rect">
             <a:avLst/>
@@ -4801,7 +5122,7 @@
           <a:lstStyle xmlns:a="http://schemas.openxmlformats.org/drawingml/2006/main"/>
           <a:p xmlns:a="http://schemas.openxmlformats.org/drawingml/2006/main">
             <a:pPr>
-              <a:defRPr sz="2550" b="1">
+              <a:defRPr sz="3300" b="1">
                 <a:solidFill>
                   <a:srgbClr val="006B68"/>
                 </a:solidFill>
@@ -4811,7 +5132,7 @@
               </a:defRPr>
             </a:pPr>
             <a:r>
-              <a:rPr sz="2550" b="1">
+              <a:rPr sz="3300" b="1">
                 <a:solidFill>
                   <a:srgbClr val="006B68"/>
                 </a:solidFill>
@@ -4819,7 +5140,7 @@
                 <a:ea typeface="Calibri"/>
                 <a:cs typeface="Calibri"/>
               </a:rPr>
-              <a:t>Datos empresariales</a:t>
+              <a:t>22 pruebas aprobadas</a:t>
             </a:r>
           </a:p>
         </p:txBody>
@@ -4829,7 +5150,7 @@
           <p:cNvPr id="4" name="">
             <a:extLst xmlns:a="http://schemas.openxmlformats.org/drawingml/2006/main">
               <a:ext uri="{FF2B5EF4-FFF2-40B4-BE49-F238E27FC236}">
-                <a16:creationId xmlns:a16="http://schemas.microsoft.com/office/drawing/2014/main" id="{45188053-8062-47C2-88C0-E0BB3CA8647B}"/>
+                <a16:creationId xmlns:a16="http://schemas.microsoft.com/office/drawing/2014/main" id="{EDEE51F2-DBE9-4F51-8981-3C4840D20FEC}"/>
               </a:ext>
             </a:extLst>
           </p:cNvPr>
@@ -4841,7 +5162,7 @@
         <p:spPr>
           <a:xfrm xmlns:a="http://schemas.openxmlformats.org/drawingml/2006/main">
             <a:off x="619125" y="2667000"/>
-            <a:ext cx="5048250" cy="2286000"/>
+            <a:ext cx="10477500" cy="857250"/>
           </a:xfrm>
           <a:prstGeom xmlns:a="http://schemas.openxmlformats.org/drawingml/2006/main" prst="rect">
             <a:avLst/>
@@ -4858,48 +5179,25 @@
           <a:lstStyle xmlns:a="http://schemas.openxmlformats.org/drawingml/2006/main"/>
           <a:p xmlns:a="http://schemas.openxmlformats.org/drawingml/2006/main">
             <a:pPr>
-              <a:defRPr sz="2325" b="0">
-                <a:solidFill>
-                  <a:srgbClr val="173345"/>
-                </a:solidFill>
-                <a:latin typeface="Calibri"/>
-                <a:ea typeface="Calibri"/>
-                <a:cs typeface="Calibri"/>
-              </a:defRPr>
-            </a:pPr>
-            <a:r>
-              <a:rPr sz="2325" b="0">
-                <a:solidFill>
-                  <a:srgbClr val="173345"/>
-                </a:solidFill>
-                <a:latin typeface="Calibri"/>
-                <a:ea typeface="Calibri"/>
-                <a:cs typeface="Calibri"/>
-              </a:rPr>
-              <a:t>Verificar origen y calidad.</a:t>
-            </a:r>
-          </a:p>
-          <a:p xmlns:a="http://schemas.openxmlformats.org/drawingml/2006/main">
-            <a:pPr>
-              <a:defRPr sz="2325" b="0">
-                <a:solidFill>
-                  <a:srgbClr val="173345"/>
-                </a:solidFill>
-                <a:latin typeface="Calibri"/>
-                <a:ea typeface="Calibri"/>
-                <a:cs typeface="Calibri"/>
-              </a:defRPr>
-            </a:pPr>
-            <a:r>
-              <a:rPr sz="2325" b="0">
-                <a:solidFill>
-                  <a:srgbClr val="173345"/>
-                </a:solidFill>
-                <a:latin typeface="Calibri"/>
-                <a:ea typeface="Calibri"/>
-                <a:cs typeface="Calibri"/>
-              </a:rPr>
-              <a:t>Reentrenar y evaluar errores por zona y costos operativos.</a:t>
+              <a:defRPr sz="2175" b="0">
+                <a:solidFill>
+                  <a:srgbClr val="173345"/>
+                </a:solidFill>
+                <a:latin typeface="Calibri"/>
+                <a:ea typeface="Calibri"/>
+                <a:cs typeface="Calibri"/>
+              </a:defRPr>
+            </a:pPr>
+            <a:r>
+              <a:rPr sz="2175" b="0">
+                <a:solidFill>
+                  <a:srgbClr val="173345"/>
+                </a:solidFill>
+                <a:latin typeface="Calibri"/>
+                <a:ea typeface="Calibri"/>
+                <a:cs typeface="Calibri"/>
+              </a:rPr>
+              <a:t>Predicciones, entradas inválidas, integración y fallos del servicio</a:t>
             </a:r>
           </a:p>
         </p:txBody>
@@ -4909,7 +5207,7 @@
           <p:cNvPr id="5" name="">
             <a:extLst xmlns:a="http://schemas.openxmlformats.org/drawingml/2006/main">
               <a:ext uri="{FF2B5EF4-FFF2-40B4-BE49-F238E27FC236}">
-                <a16:creationId xmlns:a16="http://schemas.microsoft.com/office/drawing/2014/main" id="{F24C9C47-1A9F-4C93-B358-4A6488DCA3A7}"/>
+                <a16:creationId xmlns:a16="http://schemas.microsoft.com/office/drawing/2014/main" id="{F30E2F2B-2B0A-43FE-8EE5-B97B007C18BE}"/>
               </a:ext>
             </a:extLst>
           </p:cNvPr>
@@ -4920,8 +5218,8 @@
         </p:nvSpPr>
         <p:spPr>
           <a:xfrm xmlns:a="http://schemas.openxmlformats.org/drawingml/2006/main">
-            <a:off x="6524625" y="1714500"/>
-            <a:ext cx="4953000" cy="857250"/>
+            <a:off x="619125" y="3810000"/>
+            <a:ext cx="6667500" cy="1809750"/>
           </a:xfrm>
           <a:prstGeom xmlns:a="http://schemas.openxmlformats.org/drawingml/2006/main" prst="rect">
             <a:avLst/>
@@ -4938,25 +5236,71 @@
           <a:lstStyle xmlns:a="http://schemas.openxmlformats.org/drawingml/2006/main"/>
           <a:p xmlns:a="http://schemas.openxmlformats.org/drawingml/2006/main">
             <a:pPr>
-              <a:defRPr sz="2550" b="1">
-                <a:solidFill>
-                  <a:srgbClr val="006B68"/>
-                </a:solidFill>
-                <a:latin typeface="Calibri"/>
-                <a:ea typeface="Calibri"/>
-                <a:cs typeface="Calibri"/>
-              </a:defRPr>
-            </a:pPr>
-            <a:r>
-              <a:rPr sz="2550" b="1">
-                <a:solidFill>
-                  <a:srgbClr val="006B68"/>
-                </a:solidFill>
-                <a:latin typeface="Calibri"/>
-                <a:ea typeface="Calibri"/>
-                <a:cs typeface="Calibri"/>
-              </a:rPr>
-              <a:t>Usabilidad con participantes</a:t>
+              <a:defRPr sz="2400" b="0">
+                <a:solidFill>
+                  <a:srgbClr val="173345"/>
+                </a:solidFill>
+                <a:latin typeface="Calibri"/>
+                <a:ea typeface="Calibri"/>
+                <a:cs typeface="Calibri"/>
+              </a:defRPr>
+            </a:pPr>
+            <a:r>
+              <a:rPr sz="2400" b="0">
+                <a:solidFill>
+                  <a:srgbClr val="173345"/>
+                </a:solidFill>
+                <a:latin typeface="Calibri"/>
+                <a:ea typeface="Calibri"/>
+                <a:cs typeface="Calibri"/>
+              </a:rPr>
+              <a:t>API: p95 41.9 ms</a:t>
+            </a:r>
+          </a:p>
+          <a:p xmlns:a="http://schemas.openxmlformats.org/drawingml/2006/main">
+            <a:pPr>
+              <a:defRPr sz="2400" b="0">
+                <a:solidFill>
+                  <a:srgbClr val="173345"/>
+                </a:solidFill>
+                <a:latin typeface="Calibri"/>
+                <a:ea typeface="Calibri"/>
+                <a:cs typeface="Calibri"/>
+              </a:defRPr>
+            </a:pPr>
+            <a:r>
+              <a:rPr sz="2400" b="0">
+                <a:solidFill>
+                  <a:srgbClr val="173345"/>
+                </a:solidFill>
+                <a:latin typeface="Calibri"/>
+                <a:ea typeface="Calibri"/>
+                <a:cs typeface="Calibri"/>
+              </a:rPr>
+              <a:t>Web y API: p95 85.5 ms</a:t>
+            </a:r>
+          </a:p>
+          <a:p xmlns:a="http://schemas.openxmlformats.org/drawingml/2006/main">
+            <a:pPr>
+              <a:defRPr sz="2400" b="0">
+                <a:solidFill>
+                  <a:srgbClr val="173345"/>
+                </a:solidFill>
+                <a:latin typeface="Calibri"/>
+                <a:ea typeface="Calibri"/>
+                <a:cs typeface="Calibri"/>
+              </a:defRPr>
+            </a:pPr>
+            <a:r>
+              <a:rPr sz="2400" b="0">
+                <a:solidFill>
+                  <a:srgbClr val="173345"/>
+                </a:solidFill>
+                <a:latin typeface="Calibri"/>
+                <a:ea typeface="Calibri"/>
+                <a:cs typeface="Calibri"/>
+              </a:rPr>
+              <a:t>0 errores en ambos escenarios</a:t>
             </a:r>
           </a:p>
         </p:txBody>
@@ -4966,7 +5310,7 @@
           <p:cNvPr id="6" name="">
             <a:extLst xmlns:a="http://schemas.openxmlformats.org/drawingml/2006/main">
               <a:ext uri="{FF2B5EF4-FFF2-40B4-BE49-F238E27FC236}">
-                <a16:creationId xmlns:a16="http://schemas.microsoft.com/office/drawing/2014/main" id="{D2D7F226-8F96-406F-AD71-3D3596B0F356}"/>
+                <a16:creationId xmlns:a16="http://schemas.microsoft.com/office/drawing/2014/main" id="{8803B4C3-480A-40A6-BED3-53819C694FC7}"/>
               </a:ext>
             </a:extLst>
           </p:cNvPr>
@@ -4977,8 +5321,8 @@
         </p:nvSpPr>
         <p:spPr>
           <a:xfrm xmlns:a="http://schemas.openxmlformats.org/drawingml/2006/main">
-            <a:off x="6524625" y="2857500"/>
-            <a:ext cx="5048250" cy="2571750"/>
+            <a:off x="8286750" y="3952875"/>
+            <a:ext cx="3143250" cy="1619250"/>
           </a:xfrm>
           <a:prstGeom xmlns:a="http://schemas.openxmlformats.org/drawingml/2006/main" prst="rect">
             <a:avLst/>
@@ -5013,7 +5357,7 @@
                 <a:ea typeface="Calibri"/>
                 <a:cs typeface="Calibri"/>
               </a:rPr>
-              <a:t>Realizar tareas con 3–5 personas.</a:t>
+              <a:t>100 solicitudes</a:t>
             </a:r>
           </a:p>
           <a:p xmlns:a="http://schemas.openxmlformats.org/drawingml/2006/main">
@@ -5036,7 +5380,7 @@
                 <a:ea typeface="Calibri"/>
                 <a:cs typeface="Calibri"/>
               </a:rPr>
-              <a:t>Registrar éxito, tiempo y dificultades.</a:t>
+              <a:t>10 concurrentes</a:t>
             </a:r>
           </a:p>
           <a:p xmlns:a="http://schemas.openxmlformats.org/drawingml/2006/main">
@@ -5059,7 +5403,7 @@
                 <a:ea typeface="Calibri"/>
                 <a:cs typeface="Calibri"/>
               </a:rPr>
-              <a:t>Corregir y volver a probar.</a:t>
+              <a:t>por escenario</a:t>
             </a:r>
           </a:p>
         </p:txBody>
@@ -5067,7 +5411,7 @@
     </p:spTree>
     <p:extLst>
       <p:ext uri="{BB962C8B-B14F-4D97-AF65-F5344CB8AC3E}">
-        <p14:creationId xmlns:p14="http://schemas.microsoft.com/office/powerpoint/2010/main" val="1821283109"/>
+        <p14:creationId xmlns:p14="http://schemas.microsoft.com/office/powerpoint/2010/main" val="1861005311"/>
       </p:ext>
     </p:extLst>
   </p:cSld>
@@ -5095,10 +5439,10 @@
       </p:grpSpPr>
       <p:sp>
         <p:nvSpPr>
-          <p:cNvPr id="6" name="">
+          <p:cNvPr id="7" name="">
             <a:extLst xmlns:a="http://schemas.openxmlformats.org/drawingml/2006/main">
               <a:ext uri="{FF2B5EF4-FFF2-40B4-BE49-F238E27FC236}">
-                <a16:creationId xmlns:a16="http://schemas.microsoft.com/office/drawing/2014/main" id="{C14329BA-0835-4EC8-94A3-EE0BE6E7F2DF}"/>
+                <a16:creationId xmlns:a16="http://schemas.microsoft.com/office/drawing/2014/main" id="{3AE6B857-29AF-404C-A03A-2E6FA63FD109}"/>
               </a:ext>
             </a:extLst>
           </p:cNvPr>
@@ -5145,7 +5489,7 @@
                 <a:ea typeface="Calibri"/>
                 <a:cs typeface="Calibri"/>
               </a:rPr>
-              <a:t>Entregables y cierre</a:t>
+              <a:t>Validación pendiente</a:t>
             </a:r>
           </a:p>
         </p:txBody>
@@ -5155,7 +5499,7 @@
           <p:cNvPr id="2" name="">
             <a:extLst xmlns:a="http://schemas.openxmlformats.org/drawingml/2006/main">
               <a:ext uri="{FF2B5EF4-FFF2-40B4-BE49-F238E27FC236}">
-                <a16:creationId xmlns:a16="http://schemas.microsoft.com/office/drawing/2014/main" id="{E6C01783-3E8A-4ABA-94C4-6D0511E5CA54}"/>
+                <a16:creationId xmlns:a16="http://schemas.microsoft.com/office/drawing/2014/main" id="{3B78CFFC-2A68-4BD9-BD63-44FDFB9BE4B6}"/>
               </a:ext>
             </a:extLst>
           </p:cNvPr>
@@ -5212,7 +5556,7 @@
           <p:cNvPr id="3" name="">
             <a:extLst xmlns:a="http://schemas.openxmlformats.org/drawingml/2006/main">
               <a:ext uri="{FF2B5EF4-FFF2-40B4-BE49-F238E27FC236}">
-                <a16:creationId xmlns:a16="http://schemas.microsoft.com/office/drawing/2014/main" id="{BFB661C4-E002-4DBC-941C-1EEEE30D0EC9}"/>
+                <a16:creationId xmlns:a16="http://schemas.microsoft.com/office/drawing/2014/main" id="{00E4271D-5CA0-4E0E-9AB8-F9C91A778AC7}"/>
               </a:ext>
             </a:extLst>
           </p:cNvPr>
@@ -5223,8 +5567,8 @@
         </p:nvSpPr>
         <p:spPr>
           <a:xfrm xmlns:a="http://schemas.openxmlformats.org/drawingml/2006/main">
-            <a:off x="619125" y="1809750"/>
-            <a:ext cx="10477500" cy="904875"/>
+            <a:off x="619125" y="1714500"/>
+            <a:ext cx="5238750" cy="666750"/>
           </a:xfrm>
           <a:prstGeom xmlns:a="http://schemas.openxmlformats.org/drawingml/2006/main" prst="rect">
             <a:avLst/>
@@ -5241,25 +5585,25 @@
           <a:lstStyle xmlns:a="http://schemas.openxmlformats.org/drawingml/2006/main"/>
           <a:p xmlns:a="http://schemas.openxmlformats.org/drawingml/2006/main">
             <a:pPr>
-              <a:defRPr sz="2475" b="0">
-                <a:solidFill>
-                  <a:srgbClr val="173345"/>
-                </a:solidFill>
-                <a:latin typeface="Calibri"/>
-                <a:ea typeface="Calibri"/>
-                <a:cs typeface="Calibri"/>
-              </a:defRPr>
-            </a:pPr>
-            <a:r>
-              <a:rPr sz="2475" b="0">
-                <a:solidFill>
-                  <a:srgbClr val="173345"/>
-                </a:solidFill>
-                <a:latin typeface="Calibri"/>
-                <a:ea typeface="Calibri"/>
-                <a:cs typeface="Calibri"/>
-              </a:rPr>
-              <a:t>Informe Word y PDF con diez páginas de desarrollo guiado</a:t>
+              <a:defRPr sz="2550" b="1">
+                <a:solidFill>
+                  <a:srgbClr val="006B68"/>
+                </a:solidFill>
+                <a:latin typeface="Calibri"/>
+                <a:ea typeface="Calibri"/>
+                <a:cs typeface="Calibri"/>
+              </a:defRPr>
+            </a:pPr>
+            <a:r>
+              <a:rPr sz="2550" b="1">
+                <a:solidFill>
+                  <a:srgbClr val="006B68"/>
+                </a:solidFill>
+                <a:latin typeface="Calibri"/>
+                <a:ea typeface="Calibri"/>
+                <a:cs typeface="Calibri"/>
+              </a:rPr>
+              <a:t>Datos empresariales</a:t>
             </a:r>
           </a:p>
         </p:txBody>
@@ -5269,7 +5613,7 @@
           <p:cNvPr id="4" name="">
             <a:extLst xmlns:a="http://schemas.openxmlformats.org/drawingml/2006/main">
               <a:ext uri="{FF2B5EF4-FFF2-40B4-BE49-F238E27FC236}">
-                <a16:creationId xmlns:a16="http://schemas.microsoft.com/office/drawing/2014/main" id="{52F320BE-E224-481D-8C1E-A4B6BADEF421}"/>
+                <a16:creationId xmlns:a16="http://schemas.microsoft.com/office/drawing/2014/main" id="{8D634902-A6B1-4496-A6E4-69660D31029C}"/>
               </a:ext>
             </a:extLst>
           </p:cNvPr>
@@ -5280,8 +5624,8 @@
         </p:nvSpPr>
         <p:spPr>
           <a:xfrm xmlns:a="http://schemas.openxmlformats.org/drawingml/2006/main">
-            <a:off x="619125" y="3143250"/>
-            <a:ext cx="10477500" cy="762000"/>
+            <a:off x="619125" y="2667000"/>
+            <a:ext cx="5048250" cy="2286000"/>
           </a:xfrm>
           <a:prstGeom xmlns:a="http://schemas.openxmlformats.org/drawingml/2006/main" prst="rect">
             <a:avLst/>
@@ -5298,25 +5642,48 @@
           <a:lstStyle xmlns:a="http://schemas.openxmlformats.org/drawingml/2006/main"/>
           <a:p xmlns:a="http://schemas.openxmlformats.org/drawingml/2006/main">
             <a:pPr>
-              <a:defRPr sz="2475" b="0">
-                <a:solidFill>
-                  <a:srgbClr val="173345"/>
-                </a:solidFill>
-                <a:latin typeface="Calibri"/>
-                <a:ea typeface="Calibri"/>
-                <a:cs typeface="Calibri"/>
-              </a:defRPr>
-            </a:pPr>
-            <a:r>
-              <a:rPr sz="2475" b="0">
-                <a:solidFill>
-                  <a:srgbClr val="173345"/>
-                </a:solidFill>
-                <a:latin typeface="Calibri"/>
-                <a:ea typeface="Calibri"/>
-                <a:cs typeface="Calibri"/>
-              </a:rPr>
-              <a:t>Código, modelo, pruebas y evidencia de ejecución</a:t>
+              <a:defRPr sz="2325" b="0">
+                <a:solidFill>
+                  <a:srgbClr val="173345"/>
+                </a:solidFill>
+                <a:latin typeface="Calibri"/>
+                <a:ea typeface="Calibri"/>
+                <a:cs typeface="Calibri"/>
+              </a:defRPr>
+            </a:pPr>
+            <a:r>
+              <a:rPr sz="2325" b="0">
+                <a:solidFill>
+                  <a:srgbClr val="173345"/>
+                </a:solidFill>
+                <a:latin typeface="Calibri"/>
+                <a:ea typeface="Calibri"/>
+                <a:cs typeface="Calibri"/>
+              </a:rPr>
+              <a:t>Verificar origen y calidad.</a:t>
+            </a:r>
+          </a:p>
+          <a:p xmlns:a="http://schemas.openxmlformats.org/drawingml/2006/main">
+            <a:pPr>
+              <a:defRPr sz="2325" b="0">
+                <a:solidFill>
+                  <a:srgbClr val="173345"/>
+                </a:solidFill>
+                <a:latin typeface="Calibri"/>
+                <a:ea typeface="Calibri"/>
+                <a:cs typeface="Calibri"/>
+              </a:defRPr>
+            </a:pPr>
+            <a:r>
+              <a:rPr sz="2325" b="0">
+                <a:solidFill>
+                  <a:srgbClr val="173345"/>
+                </a:solidFill>
+                <a:latin typeface="Calibri"/>
+                <a:ea typeface="Calibri"/>
+                <a:cs typeface="Calibri"/>
+              </a:rPr>
+              <a:t>Reentrenar y evaluar errores por zona y costos operativos.</a:t>
             </a:r>
           </a:p>
         </p:txBody>
@@ -5326,7 +5693,7 @@
           <p:cNvPr id="5" name="">
             <a:extLst xmlns:a="http://schemas.openxmlformats.org/drawingml/2006/main">
               <a:ext uri="{FF2B5EF4-FFF2-40B4-BE49-F238E27FC236}">
-                <a16:creationId xmlns:a16="http://schemas.microsoft.com/office/drawing/2014/main" id="{86F3B0D7-63E0-47C2-B150-5C93486ED5F1}"/>
+                <a16:creationId xmlns:a16="http://schemas.microsoft.com/office/drawing/2014/main" id="{89BE54F6-12E1-4378-AC6B-AA963770840D}"/>
               </a:ext>
             </a:extLst>
           </p:cNvPr>
@@ -5337,8 +5704,8 @@
         </p:nvSpPr>
         <p:spPr>
           <a:xfrm xmlns:a="http://schemas.openxmlformats.org/drawingml/2006/main">
-            <a:off x="619125" y="4476750"/>
-            <a:ext cx="10477500" cy="1143000"/>
+            <a:off x="6524625" y="1714500"/>
+            <a:ext cx="4953000" cy="857250"/>
           </a:xfrm>
           <a:prstGeom xmlns:a="http://schemas.openxmlformats.org/drawingml/2006/main" prst="rect">
             <a:avLst/>
@@ -5355,7 +5722,7 @@
           <a:lstStyle xmlns:a="http://schemas.openxmlformats.org/drawingml/2006/main"/>
           <a:p xmlns:a="http://schemas.openxmlformats.org/drawingml/2006/main">
             <a:pPr>
-              <a:defRPr sz="2325" b="1">
+              <a:defRPr sz="2550" b="1">
                 <a:solidFill>
                   <a:srgbClr val="006B68"/>
                 </a:solidFill>
@@ -5365,7 +5732,7 @@
               </a:defRPr>
             </a:pPr>
             <a:r>
-              <a:rPr sz="2325" b="1">
+              <a:rPr sz="2550" b="1">
                 <a:solidFill>
                   <a:srgbClr val="006B68"/>
                 </a:solidFill>
@@ -5373,30 +5740,110 @@
                 <a:ea typeface="Calibri"/>
                 <a:cs typeface="Calibri"/>
               </a:rPr>
-              <a:t>Pendiente: completar antecedentes, validar con usuarios</a:t>
-            </a:r>
-          </a:p>
-          <a:p xmlns:a="http://schemas.openxmlformats.org/drawingml/2006/main">
-            <a:pPr>
-              <a:defRPr sz="2325" b="1">
-                <a:solidFill>
-                  <a:srgbClr val="006B68"/>
-                </a:solidFill>
-                <a:latin typeface="Calibri"/>
-                <a:ea typeface="Calibri"/>
-                <a:cs typeface="Calibri"/>
-              </a:defRPr>
-            </a:pPr>
-            <a:r>
-              <a:rPr sz="2325" b="1">
-                <a:solidFill>
-                  <a:srgbClr val="006B68"/>
-                </a:solidFill>
-                <a:latin typeface="Calibri"/>
-                <a:ea typeface="Calibri"/>
-                <a:cs typeface="Calibri"/>
-              </a:rPr>
-              <a:t>y publicar el repositorio en GitHub</a:t>
+              <a:t>Usabilidad con participantes</a:t>
+            </a:r>
+          </a:p>
+        </p:txBody>
+      </p:sp>
+      <p:sp>
+        <p:nvSpPr>
+          <p:cNvPr id="6" name="">
+            <a:extLst xmlns:a="http://schemas.openxmlformats.org/drawingml/2006/main">
+              <a:ext uri="{FF2B5EF4-FFF2-40B4-BE49-F238E27FC236}">
+                <a16:creationId xmlns:a16="http://schemas.microsoft.com/office/drawing/2014/main" id="{8505C50B-5B88-44FC-983E-4BCE1A438C68}"/>
+              </a:ext>
+            </a:extLst>
+          </p:cNvPr>
+          <p:cNvSpPr>
+            <a:spLocks xmlns:a="http://schemas.openxmlformats.org/drawingml/2006/main" noGrp="1"/>
+          </p:cNvSpPr>
+          <p:nvPr/>
+        </p:nvSpPr>
+        <p:spPr>
+          <a:xfrm xmlns:a="http://schemas.openxmlformats.org/drawingml/2006/main">
+            <a:off x="6524625" y="2857500"/>
+            <a:ext cx="5048250" cy="2571750"/>
+          </a:xfrm>
+          <a:prstGeom xmlns:a="http://schemas.openxmlformats.org/drawingml/2006/main" prst="rect">
+            <a:avLst/>
+          </a:prstGeom>
+          <a:noFill xmlns:a="http://schemas.openxmlformats.org/drawingml/2006/main"/>
+          <a:ln xmlns:a="http://schemas.openxmlformats.org/drawingml/2006/main" w="0">
+            <a:noFill/>
+          </a:ln>
+        </p:spPr>
+        <p:txBody>
+          <a:bodyPr xmlns:a="http://schemas.openxmlformats.org/drawingml/2006/main">
+            <a:noAutofit/>
+          </a:bodyPr>
+          <a:lstStyle xmlns:a="http://schemas.openxmlformats.org/drawingml/2006/main"/>
+          <a:p xmlns:a="http://schemas.openxmlformats.org/drawingml/2006/main">
+            <a:pPr>
+              <a:defRPr sz="2250" b="0">
+                <a:solidFill>
+                  <a:srgbClr val="173345"/>
+                </a:solidFill>
+                <a:latin typeface="Calibri"/>
+                <a:ea typeface="Calibri"/>
+                <a:cs typeface="Calibri"/>
+              </a:defRPr>
+            </a:pPr>
+            <a:r>
+              <a:rPr sz="2250" b="0">
+                <a:solidFill>
+                  <a:srgbClr val="173345"/>
+                </a:solidFill>
+                <a:latin typeface="Calibri"/>
+                <a:ea typeface="Calibri"/>
+                <a:cs typeface="Calibri"/>
+              </a:rPr>
+              <a:t>Realizar tareas con 3–5 personas.</a:t>
+            </a:r>
+          </a:p>
+          <a:p xmlns:a="http://schemas.openxmlformats.org/drawingml/2006/main">
+            <a:pPr>
+              <a:defRPr sz="2250" b="0">
+                <a:solidFill>
+                  <a:srgbClr val="173345"/>
+                </a:solidFill>
+                <a:latin typeface="Calibri"/>
+                <a:ea typeface="Calibri"/>
+                <a:cs typeface="Calibri"/>
+              </a:defRPr>
+            </a:pPr>
+            <a:r>
+              <a:rPr sz="2250" b="0">
+                <a:solidFill>
+                  <a:srgbClr val="173345"/>
+                </a:solidFill>
+                <a:latin typeface="Calibri"/>
+                <a:ea typeface="Calibri"/>
+                <a:cs typeface="Calibri"/>
+              </a:rPr>
+              <a:t>Registrar éxito, tiempo y dificultades.</a:t>
+            </a:r>
+          </a:p>
+          <a:p xmlns:a="http://schemas.openxmlformats.org/drawingml/2006/main">
+            <a:pPr>
+              <a:defRPr sz="2250" b="0">
+                <a:solidFill>
+                  <a:srgbClr val="173345"/>
+                </a:solidFill>
+                <a:latin typeface="Calibri"/>
+                <a:ea typeface="Calibri"/>
+                <a:cs typeface="Calibri"/>
+              </a:defRPr>
+            </a:pPr>
+            <a:r>
+              <a:rPr sz="2250" b="0">
+                <a:solidFill>
+                  <a:srgbClr val="173345"/>
+                </a:solidFill>
+                <a:latin typeface="Calibri"/>
+                <a:ea typeface="Calibri"/>
+                <a:cs typeface="Calibri"/>
+              </a:rPr>
+              <a:t>Corregir y volver a probar.</a:t>
             </a:r>
           </a:p>
         </p:txBody>
@@ -5404,7 +5851,7 @@
     </p:spTree>
     <p:extLst>
       <p:ext uri="{BB962C8B-B14F-4D97-AF65-F5344CB8AC3E}">
-        <p14:creationId xmlns:p14="http://schemas.microsoft.com/office/powerpoint/2010/main" val="579235078"/>
+        <p14:creationId xmlns:p14="http://schemas.microsoft.com/office/powerpoint/2010/main" val="1330896556"/>
       </p:ext>
     </p:extLst>
   </p:cSld>

</xml_diff>